<commit_message>
Utilisation: take Argenis and Karim's Thu-Fri leave out of the base
Both were out Thursday and Friday: 4 days x 7.6h = 30.4h off the 342h
base, so available is 311.6h and this week's utilisation reads 3.7%
rather than 3.4%. Billed hours are unchanged at 11.5h.

Partial-week leave can't be shown as whole people on leave, so the
utilisation slide takes optional availableNote / availableCalc text for
the capacity KPI and the TOTAL row.

Co-Authored-By: Claude Opus 5.5 <noreply@anthropic.com>
Claude-Session: https://claude.ai/code/session_01Lq5maWicgiSj2RkHzTdcCm
</commit_message>
<xml_diff>
--- a/exec-deck/output/H&L Weekly Update - WC 19 Oct 2026.pptx
+++ b/exec-deck/output/H&L Weekly Update - WC 19 Oct 2026.pptx
@@ -25654,7 +25654,7 @@
                 <a:ea typeface="Poppins" pitchFamily="34" charset="-122"/>
                 <a:cs typeface="Poppins" pitchFamily="34" charset="-120"/>
               </a:rPr>
-              <a:t>billable utilisation 3.4% so far — 11.5h of 342h logged Mon–Fri; last week restated 13.0% → 16.8% (39.45h → 51.02h), so this is a floor</a:t>
+              <a:t>billable utilisation 3.7% so far — 11.5h of 311.6h (Argenis and Karim out Thu–Fri); last week restated 13.0% → 16.8% (39.45h → 51.02h), so this is a floor</a:t>
             </a:r>
             <a:endParaRPr lang="en-US" sz="900" dirty="0"/>
           </a:p>
@@ -39685,7 +39685,7 @@
                 <a:ea typeface="Poppins" pitchFamily="34" charset="-122"/>
                 <a:cs typeface="Poppins" pitchFamily="34" charset="-120"/>
               </a:rPr>
-              <a:t>3.4%</a:t>
+              <a:t>3.7%</a:t>
             </a:r>
             <a:endParaRPr lang="en-US" sz="2600" dirty="0"/>
           </a:p>
@@ -39724,7 +39724,7 @@
                 <a:ea typeface="Poppins" pitchFamily="34" charset="-122"/>
                 <a:cs typeface="Poppins" pitchFamily="34" charset="-120"/>
               </a:rPr>
-              <a:t>11.5h billed of 342h available · target 50% · partial week</a:t>
+              <a:t>11.5h billed of 311.6h available · target 50% · partial week</a:t>
             </a:r>
             <a:endParaRPr lang="en-US" sz="780" dirty="0"/>
           </a:p>
@@ -39831,7 +39831,7 @@
                 <a:ea typeface="Poppins" pitchFamily="34" charset="-122"/>
                 <a:cs typeface="Poppins" pitchFamily="34" charset="-120"/>
               </a:rPr>
-              <a:t>342h</a:t>
+              <a:t>311.6h</a:t>
             </a:r>
             <a:endParaRPr lang="en-US" sz="2600" dirty="0"/>
           </a:p>
@@ -39870,7 +39870,7 @@
                 <a:ea typeface="Poppins" pitchFamily="34" charset="-122"/>
                 <a:cs typeface="Poppins" pitchFamily="34" charset="-120"/>
               </a:rPr>
-              <a:t>9 people assigned to PS-pipeline tickets × 38h standard week</a:t>
+              <a:t>9 PS people × 38h, less Thu–Fri leave for Argenis Rafael Guevara and Karim AlRifaii (4 days × 7.6h)</a:t>
             </a:r>
             <a:endParaRPr lang="en-US" sz="780" dirty="0"/>
           </a:p>
@@ -41986,7 +41986,7 @@
                 <a:ea typeface="Poppins" pitchFamily="34" charset="-122"/>
                 <a:cs typeface="Poppins" pitchFamily="34" charset="-120"/>
               </a:rPr>
-              <a:t>9 PS people × 38h = 342h available</a:t>
+              <a:t>9 × 38h − 30.4h leave = 311.6h available</a:t>
             </a:r>
             <a:endParaRPr lang="en-US" sz="700" dirty="0"/>
           </a:p>
@@ -42064,7 +42064,7 @@
                 <a:ea typeface="Poppins" pitchFamily="34" charset="-122"/>
                 <a:cs typeface="Poppins" pitchFamily="34" charset="-120"/>
               </a:rPr>
-              <a:t>3.4%</a:t>
+              <a:t>3.7%</a:t>
             </a:r>
             <a:endParaRPr lang="en-US" sz="950" dirty="0"/>
           </a:p>
@@ -42103,7 +42103,7 @@
                 <a:ea typeface="Poppins" pitchFamily="34" charset="-122"/>
                 <a:cs typeface="Poppins" pitchFamily="34" charset="-120"/>
               </a:rPr>
-              <a:t>Available staff = the 9 Professional Services people holding PS-pipeline tickets this week at 38h each — Isayah Kuhlmann is back and logging; leave for the week is not yet confirmed. Lopez, Hikuroa, Magabo, Ho, Fenwick and Hettiarachchy hold PS tickets but are not PS staff — excluded; none carried hours. Hours logged Mon–Fri only; the week closes Sunday.</a:t>
+              <a:t>Available staff = the 9 Professional Services people holding PS-pipeline tickets this week at 38h each (7.6h a day), less Thursday and Friday leave for Argenis Rafael Guevara and Karim AlRifaii — 30.4h. Isayah Kuhlmann is back and logging. Lopez, Hikuroa, Magabo, Ho, Fenwick and Hettiarachchy hold PS tickets but are not PS staff — excluded; none carried hours. Hours logged Mon–Fri only; the week closes Sunday.</a:t>
             </a:r>
             <a:endParaRPr lang="en-US" sz="580" dirty="0"/>
           </a:p>
@@ -44315,7 +44315,7 @@
                 <a:ea typeface="Poppins" pitchFamily="34" charset="-122"/>
                 <a:cs typeface="Poppins" pitchFamily="34" charset="-120"/>
               </a:rPr>
-              <a:t>3.4%</a:t>
+              <a:t>3.7%</a:t>
             </a:r>
             <a:endParaRPr lang="en-US" sz="750" dirty="0"/>
           </a:p>
@@ -44393,7 +44393,7 @@
                 <a:ea typeface="Poppins" pitchFamily="34" charset="-122"/>
                 <a:cs typeface="Poppins" pitchFamily="34" charset="-120"/>
               </a:rPr>
-              <a:t>Base is available staff × 38h: 7 for 28 Sep–4 Oct (Rhys and Rodney on leave), 9 for 5–11 Oct, 8 for 12–18 Oct (Isayah on leave) and 9 this week. PS-pipeline tickets by Sydney week, re-pulled 24 Oct.</a:t>
+              <a:t>Base is available staff × 38h: 7 for 28 Sep–4 Oct (Rhys and Rodney on leave), 9 for 5–11 Oct, 8 for 12–18 Oct (Isayah on leave) and 9 this week less two days each for Argenis and Karim. PS-pipeline tickets by Sydney week, re-pulled 24 Oct.</a:t>
             </a:r>
             <a:endParaRPr lang="en-US" sz="580" dirty="0"/>
           </a:p>
@@ -44531,7 +44531,7 @@
                 <a:ea typeface="Poppins" pitchFamily="34" charset="-122"/>
                 <a:cs typeface="Poppins" pitchFamily="34" charset="-120"/>
               </a:rPr>
-              <a:t>12–18 Oct went out at 39.45h (13.0%) and now reads 51.02h (16.8%); 5–11 Oct has grown again to 35.25h from the 21.25h first published. This week's 3.4% covers five working days logged so far and will restate upward — treat it as a floor.</a:t>
+              <a:t>12–18 Oct went out at 39.45h (13.0%) and now reads 51.02h (16.8%); 5–11 Oct has grown again to 35.25h from the 21.25h first published. This week's 3.7% covers five working days logged so far and will restate upward — treat it as a floor.</a:t>
             </a:r>
             <a:endParaRPr lang="en-US" sz="900" dirty="0"/>
           </a:p>
@@ -44579,7 +44579,7 @@
                 <a:ea typeface="Poppins" pitchFamily="34" charset="-122"/>
                 <a:cs typeface="Poppins" pitchFamily="34" charset="-120"/>
               </a:rPr>
-              <a:t>Isayah Kuhlmann 4.00h, Joshua Casey and Rodney Nolan 3.50h each, Rhys Woolcock 0.50h; Gregory, Ryan, Isaac, Argenis and Karim have no time on this week's tickets yet.</a:t>
+              <a:t>Isayah Kuhlmann 4.00h, Joshua Casey and Rodney Nolan 3.50h each, Rhys Woolcock 0.50h. Gregory, Ryan and Isaac have no time on this week's tickets yet; Argenis and Karim were out Thursday and Friday and have none from Monday to Wednesday either.</a:t>
             </a:r>
             <a:endParaRPr lang="en-US" sz="900" dirty="0"/>
           </a:p>

</xml_diff>

<commit_message>
WC 19 Oct Won vs Invoiced: PS onboarding status from PS Weekly 26 Oct
Co-Authored-By: Claude Opus 5.5 <noreply@anthropic.com>
Claude-Session: https://claude.ai/code/session_01Lq5maWicgiSj2RkHzTdcCm
</commit_message>
<xml_diff>
--- a/exec-deck/output/H&L Weekly Update - WC 19 Oct 2026.pptx
+++ b/exec-deck/output/H&L Weekly Update - WC 19 Oct 2026.pptx
@@ -47323,8 +47323,47 @@
         </p:nvSpPr>
         <p:spPr>
           <a:xfrm>
+            <a:off x="9765792" y="4352544"/>
+            <a:ext cx="1664208" cy="164592"/>
+          </a:xfrm>
+          <a:prstGeom prst="rect">
+            <a:avLst/>
+          </a:prstGeom>
+          <a:noFill/>
+          <a:ln/>
+        </p:spPr>
+        <p:txBody>
+          <a:bodyPr wrap="square" lIns="0" tIns="0" rIns="0" bIns="0" rtlCol="0" anchor="ctr"/>
+          <a:lstStyle/>
+          <a:p>
+            <a:pPr indent="0" marL="0">
+              <a:buNone/>
+            </a:pPr>
+            <a:r>
+              <a:rPr lang="en-US" sz="700" b="1" dirty="0">
+                <a:solidFill>
+                  <a:srgbClr val="8FA1AC"/>
+                </a:solidFill>
+                <a:latin typeface="Poppins" pitchFamily="34" charset="0"/>
+                <a:ea typeface="Poppins" pitchFamily="34" charset="-122"/>
+                <a:cs typeface="Poppins" pitchFamily="34" charset="-120"/>
+              </a:rPr>
+              <a:t>PS STATUS · 26 OCT</a:t>
+            </a:r>
+            <a:endParaRPr lang="en-US" sz="700" dirty="0"/>
+          </a:p>
+        </p:txBody>
+      </p:sp>
+      <p:sp>
+        <p:nvSpPr>
+          <p:cNvPr id="32" name="Text 29"/>
+          <p:cNvSpPr txBox="1"/>
+          <p:nvPr/>
+        </p:nvSpPr>
+        <p:spPr>
+          <a:xfrm>
             <a:off x="6748272" y="4352544"/>
-            <a:ext cx="2286000" cy="164592"/>
+            <a:ext cx="1371600" cy="164592"/>
           </a:xfrm>
           <a:prstGeom prst="rect">
             <a:avLst/>
@@ -47356,14 +47395,14 @@
       </p:sp>
       <p:sp>
         <p:nvSpPr>
-          <p:cNvPr id="32" name="Text 29"/>
-          <p:cNvSpPr txBox="1"/>
-          <p:nvPr/>
-        </p:nvSpPr>
-        <p:spPr>
-          <a:xfrm>
-            <a:off x="9052560" y="4352544"/>
-            <a:ext cx="822960" cy="164592"/>
+          <p:cNvPr id="33" name="Text 30"/>
+          <p:cNvSpPr txBox="1"/>
+          <p:nvPr/>
+        </p:nvSpPr>
+        <p:spPr>
+          <a:xfrm>
+            <a:off x="8138160" y="4352544"/>
+            <a:ext cx="548640" cy="164592"/>
           </a:xfrm>
           <a:prstGeom prst="rect">
             <a:avLst/>
@@ -47395,14 +47434,14 @@
       </p:sp>
       <p:sp>
         <p:nvSpPr>
-          <p:cNvPr id="33" name="Text 30"/>
-          <p:cNvSpPr txBox="1"/>
-          <p:nvPr/>
-        </p:nvSpPr>
-        <p:spPr>
-          <a:xfrm>
-            <a:off x="9921240" y="4352544"/>
-            <a:ext cx="685800" cy="164592"/>
+          <p:cNvPr id="34" name="Text 31"/>
+          <p:cNvSpPr txBox="1"/>
+          <p:nvPr/>
+        </p:nvSpPr>
+        <p:spPr>
+          <a:xfrm>
+            <a:off x="8705088" y="4352544"/>
+            <a:ext cx="548640" cy="164592"/>
           </a:xfrm>
           <a:prstGeom prst="rect">
             <a:avLst/>
@@ -47434,14 +47473,14 @@
       </p:sp>
       <p:sp>
         <p:nvSpPr>
-          <p:cNvPr id="34" name="Text 31"/>
-          <p:cNvSpPr txBox="1"/>
-          <p:nvPr/>
-        </p:nvSpPr>
-        <p:spPr>
-          <a:xfrm>
-            <a:off x="10652760" y="4352544"/>
-            <a:ext cx="457200" cy="164592"/>
+          <p:cNvPr id="35" name="Text 32"/>
+          <p:cNvSpPr txBox="1"/>
+          <p:nvPr/>
+        </p:nvSpPr>
+        <p:spPr>
+          <a:xfrm>
+            <a:off x="9281160" y="4352544"/>
+            <a:ext cx="365760" cy="164592"/>
           </a:xfrm>
           <a:prstGeom prst="rect">
             <a:avLst/>
@@ -47473,14 +47512,14 @@
       </p:sp>
       <p:sp>
         <p:nvSpPr>
-          <p:cNvPr id="35" name="Text 32"/>
-          <p:cNvSpPr txBox="1"/>
-          <p:nvPr/>
-        </p:nvSpPr>
-        <p:spPr>
-          <a:xfrm>
-            <a:off x="11155680" y="4352544"/>
-            <a:ext cx="384048" cy="164592"/>
+          <p:cNvPr id="36" name="Text 33"/>
+          <p:cNvSpPr txBox="1"/>
+          <p:nvPr/>
+        </p:nvSpPr>
+        <p:spPr>
+          <a:xfrm>
+            <a:off x="11448288" y="4352544"/>
+            <a:ext cx="182880" cy="164592"/>
           </a:xfrm>
           <a:prstGeom prst="rect">
             <a:avLst/>
@@ -47501,7 +47540,7 @@
       </p:sp>
       <p:sp>
         <p:nvSpPr>
-          <p:cNvPr id="36" name="Text 33"/>
+          <p:cNvPr id="37" name="Text 34"/>
           <p:cNvSpPr txBox="1"/>
           <p:nvPr/>
         </p:nvSpPr>
@@ -47540,14 +47579,14 @@
       </p:sp>
       <p:sp>
         <p:nvSpPr>
-          <p:cNvPr id="37" name="Text 34"/>
+          <p:cNvPr id="38" name="Text 35"/>
           <p:cNvSpPr txBox="1"/>
           <p:nvPr/>
         </p:nvSpPr>
         <p:spPr>
           <a:xfrm>
             <a:off x="6748272" y="4535424"/>
-            <a:ext cx="2286000" cy="173736"/>
+            <a:ext cx="1371600" cy="173736"/>
           </a:xfrm>
           <a:prstGeom prst="rect">
             <a:avLst/>
@@ -47579,14 +47618,14 @@
       </p:sp>
       <p:sp>
         <p:nvSpPr>
-          <p:cNvPr id="38" name="Text 35"/>
-          <p:cNvSpPr txBox="1"/>
-          <p:nvPr/>
-        </p:nvSpPr>
-        <p:spPr>
-          <a:xfrm>
-            <a:off x="9052560" y="4535424"/>
-            <a:ext cx="822960" cy="173736"/>
+          <p:cNvPr id="39" name="Text 36"/>
+          <p:cNvSpPr txBox="1"/>
+          <p:nvPr/>
+        </p:nvSpPr>
+        <p:spPr>
+          <a:xfrm>
+            <a:off x="8138160" y="4535424"/>
+            <a:ext cx="548640" cy="173736"/>
           </a:xfrm>
           <a:prstGeom prst="rect">
             <a:avLst/>
@@ -47618,14 +47657,14 @@
       </p:sp>
       <p:sp>
         <p:nvSpPr>
-          <p:cNvPr id="39" name="Text 36"/>
-          <p:cNvSpPr txBox="1"/>
-          <p:nvPr/>
-        </p:nvSpPr>
-        <p:spPr>
-          <a:xfrm>
-            <a:off x="9921240" y="4535424"/>
-            <a:ext cx="685800" cy="173736"/>
+          <p:cNvPr id="40" name="Text 37"/>
+          <p:cNvSpPr txBox="1"/>
+          <p:nvPr/>
+        </p:nvSpPr>
+        <p:spPr>
+          <a:xfrm>
+            <a:off x="8705088" y="4535424"/>
+            <a:ext cx="548640" cy="173736"/>
           </a:xfrm>
           <a:prstGeom prst="rect">
             <a:avLst/>
@@ -47657,14 +47696,14 @@
       </p:sp>
       <p:sp>
         <p:nvSpPr>
-          <p:cNvPr id="40" name="Text 37"/>
-          <p:cNvSpPr txBox="1"/>
-          <p:nvPr/>
-        </p:nvSpPr>
-        <p:spPr>
-          <a:xfrm>
-            <a:off x="10652760" y="4535424"/>
-            <a:ext cx="457200" cy="173736"/>
+          <p:cNvPr id="41" name="Text 38"/>
+          <p:cNvSpPr txBox="1"/>
+          <p:nvPr/>
+        </p:nvSpPr>
+        <p:spPr>
+          <a:xfrm>
+            <a:off x="9281160" y="4535424"/>
+            <a:ext cx="365760" cy="173736"/>
           </a:xfrm>
           <a:prstGeom prst="rect">
             <a:avLst/>
@@ -47696,14 +47735,55 @@
       </p:sp>
       <p:sp>
         <p:nvSpPr>
-          <p:cNvPr id="41" name="Text 38"/>
-          <p:cNvSpPr txBox="1"/>
-          <p:nvPr/>
-        </p:nvSpPr>
-        <p:spPr>
-          <a:xfrm>
-            <a:off x="11155680" y="4535424"/>
-            <a:ext cx="384048" cy="173736"/>
+          <p:cNvPr id="42" name="Text 39"/>
+          <p:cNvSpPr txBox="1"/>
+          <p:nvPr/>
+        </p:nvSpPr>
+        <p:spPr>
+          <a:xfrm>
+            <a:off x="9765792" y="4535424"/>
+            <a:ext cx="1664208" cy="173736"/>
+          </a:xfrm>
+          <a:prstGeom prst="rect">
+            <a:avLst/>
+          </a:prstGeom>
+          <a:noFill/>
+          <a:ln/>
+        </p:spPr>
+        <p:txBody>
+          <a:bodyPr wrap="square" lIns="0" tIns="0" rIns="0" bIns="0" rtlCol="0" anchor="ctr">
+            <a:normAutofit/>
+          </a:bodyPr>
+          <a:lstStyle/>
+          <a:p>
+            <a:pPr indent="0" marL="0">
+              <a:buNone/>
+            </a:pPr>
+            <a:r>
+              <a:rPr lang="en-US" sz="680" dirty="0">
+                <a:solidFill>
+                  <a:srgbClr val="12293A"/>
+                </a:solidFill>
+                <a:latin typeface="Poppins" pitchFamily="34" charset="0"/>
+                <a:ea typeface="Poppins" pitchFamily="34" charset="-122"/>
+                <a:cs typeface="Poppins" pitchFamily="34" charset="-120"/>
+              </a:rPr>
+              <a:t>Signed · 49 sites · live mid-Jan</a:t>
+            </a:r>
+            <a:endParaRPr lang="en-US" sz="680" dirty="0"/>
+          </a:p>
+        </p:txBody>
+      </p:sp>
+      <p:sp>
+        <p:nvSpPr>
+          <p:cNvPr id="43" name="Text 40"/>
+          <p:cNvSpPr txBox="1"/>
+          <p:nvPr/>
+        </p:nvSpPr>
+        <p:spPr>
+          <a:xfrm>
+            <a:off x="11448288" y="4535424"/>
+            <a:ext cx="182880" cy="173736"/>
           </a:xfrm>
           <a:prstGeom prst="rect">
             <a:avLst/>
@@ -47735,7 +47815,7 @@
       </p:sp>
       <p:sp>
         <p:nvSpPr>
-          <p:cNvPr id="42" name="Text 39"/>
+          <p:cNvPr id="44" name="Text 41"/>
           <p:cNvSpPr txBox="1"/>
           <p:nvPr/>
         </p:nvSpPr>
@@ -47774,14 +47854,14 @@
       </p:sp>
       <p:sp>
         <p:nvSpPr>
-          <p:cNvPr id="43" name="Text 40"/>
+          <p:cNvPr id="45" name="Text 42"/>
           <p:cNvSpPr txBox="1"/>
           <p:nvPr/>
         </p:nvSpPr>
         <p:spPr>
           <a:xfrm>
             <a:off x="6748272" y="4710989"/>
-            <a:ext cx="2286000" cy="173736"/>
+            <a:ext cx="1371600" cy="173736"/>
           </a:xfrm>
           <a:prstGeom prst="rect">
             <a:avLst/>
@@ -47813,14 +47893,14 @@
       </p:sp>
       <p:sp>
         <p:nvSpPr>
-          <p:cNvPr id="44" name="Text 41"/>
-          <p:cNvSpPr txBox="1"/>
-          <p:nvPr/>
-        </p:nvSpPr>
-        <p:spPr>
-          <a:xfrm>
-            <a:off x="9052560" y="4710989"/>
-            <a:ext cx="822960" cy="173736"/>
+          <p:cNvPr id="46" name="Text 43"/>
+          <p:cNvSpPr txBox="1"/>
+          <p:nvPr/>
+        </p:nvSpPr>
+        <p:spPr>
+          <a:xfrm>
+            <a:off x="8138160" y="4710989"/>
+            <a:ext cx="548640" cy="173736"/>
           </a:xfrm>
           <a:prstGeom prst="rect">
             <a:avLst/>
@@ -47852,14 +47932,14 @@
       </p:sp>
       <p:sp>
         <p:nvSpPr>
-          <p:cNvPr id="45" name="Text 42"/>
-          <p:cNvSpPr txBox="1"/>
-          <p:nvPr/>
-        </p:nvSpPr>
-        <p:spPr>
-          <a:xfrm>
-            <a:off x="9921240" y="4710989"/>
-            <a:ext cx="685800" cy="173736"/>
+          <p:cNvPr id="47" name="Text 44"/>
+          <p:cNvSpPr txBox="1"/>
+          <p:nvPr/>
+        </p:nvSpPr>
+        <p:spPr>
+          <a:xfrm>
+            <a:off x="8705088" y="4710989"/>
+            <a:ext cx="548640" cy="173736"/>
           </a:xfrm>
           <a:prstGeom prst="rect">
             <a:avLst/>
@@ -47891,14 +47971,14 @@
       </p:sp>
       <p:sp>
         <p:nvSpPr>
-          <p:cNvPr id="46" name="Text 43"/>
-          <p:cNvSpPr txBox="1"/>
-          <p:nvPr/>
-        </p:nvSpPr>
-        <p:spPr>
-          <a:xfrm>
-            <a:off x="10652760" y="4710989"/>
-            <a:ext cx="457200" cy="173736"/>
+          <p:cNvPr id="48" name="Text 45"/>
+          <p:cNvSpPr txBox="1"/>
+          <p:nvPr/>
+        </p:nvSpPr>
+        <p:spPr>
+          <a:xfrm>
+            <a:off x="9281160" y="4710989"/>
+            <a:ext cx="365760" cy="173736"/>
           </a:xfrm>
           <a:prstGeom prst="rect">
             <a:avLst/>
@@ -47930,14 +48010,55 @@
       </p:sp>
       <p:sp>
         <p:nvSpPr>
-          <p:cNvPr id="47" name="Text 44"/>
-          <p:cNvSpPr txBox="1"/>
-          <p:nvPr/>
-        </p:nvSpPr>
-        <p:spPr>
-          <a:xfrm>
-            <a:off x="11155680" y="4710989"/>
-            <a:ext cx="384048" cy="173736"/>
+          <p:cNvPr id="49" name="Text 46"/>
+          <p:cNvSpPr txBox="1"/>
+          <p:nvPr/>
+        </p:nvSpPr>
+        <p:spPr>
+          <a:xfrm>
+            <a:off x="9765792" y="4710989"/>
+            <a:ext cx="1664208" cy="173736"/>
+          </a:xfrm>
+          <a:prstGeom prst="rect">
+            <a:avLst/>
+          </a:prstGeom>
+          <a:noFill/>
+          <a:ln/>
+        </p:spPr>
+        <p:txBody>
+          <a:bodyPr wrap="square" lIns="0" tIns="0" rIns="0" bIns="0" rtlCol="0" anchor="ctr">
+            <a:normAutofit/>
+          </a:bodyPr>
+          <a:lstStyle/>
+          <a:p>
+            <a:pPr indent="0" marL="0">
+              <a:buNone/>
+            </a:pPr>
+            <a:r>
+              <a:rPr lang="en-US" sz="680" dirty="0">
+                <a:solidFill>
+                  <a:srgbClr val="12293A"/>
+                </a:solidFill>
+                <a:latin typeface="Poppins" pitchFamily="34" charset="0"/>
+                <a:ea typeface="Poppins" pitchFamily="34" charset="-122"/>
+                <a:cs typeface="Poppins" pitchFamily="34" charset="-120"/>
+              </a:rPr>
+              <a:t>Registration changeover</a:t>
+            </a:r>
+            <a:endParaRPr lang="en-US" sz="680" dirty="0"/>
+          </a:p>
+        </p:txBody>
+      </p:sp>
+      <p:sp>
+        <p:nvSpPr>
+          <p:cNvPr id="50" name="Text 47"/>
+          <p:cNvSpPr txBox="1"/>
+          <p:nvPr/>
+        </p:nvSpPr>
+        <p:spPr>
+          <a:xfrm>
+            <a:off x="11448288" y="4710989"/>
+            <a:ext cx="182880" cy="173736"/>
           </a:xfrm>
           <a:prstGeom prst="rect">
             <a:avLst/>
@@ -47958,7 +48079,7 @@
       </p:sp>
       <p:sp>
         <p:nvSpPr>
-          <p:cNvPr id="48" name="Text 45"/>
+          <p:cNvPr id="51" name="Text 48"/>
           <p:cNvSpPr txBox="1"/>
           <p:nvPr/>
         </p:nvSpPr>
@@ -47997,14 +48118,14 @@
       </p:sp>
       <p:sp>
         <p:nvSpPr>
-          <p:cNvPr id="49" name="Text 46"/>
+          <p:cNvPr id="52" name="Text 49"/>
           <p:cNvSpPr txBox="1"/>
           <p:nvPr/>
         </p:nvSpPr>
         <p:spPr>
           <a:xfrm>
             <a:off x="6748272" y="4886554"/>
-            <a:ext cx="2286000" cy="173736"/>
+            <a:ext cx="1371600" cy="173736"/>
           </a:xfrm>
           <a:prstGeom prst="rect">
             <a:avLst/>
@@ -48036,14 +48157,14 @@
       </p:sp>
       <p:sp>
         <p:nvSpPr>
-          <p:cNvPr id="50" name="Text 47"/>
-          <p:cNvSpPr txBox="1"/>
-          <p:nvPr/>
-        </p:nvSpPr>
-        <p:spPr>
-          <a:xfrm>
-            <a:off x="9052560" y="4886554"/>
-            <a:ext cx="822960" cy="173736"/>
+          <p:cNvPr id="53" name="Text 50"/>
+          <p:cNvSpPr txBox="1"/>
+          <p:nvPr/>
+        </p:nvSpPr>
+        <p:spPr>
+          <a:xfrm>
+            <a:off x="8138160" y="4886554"/>
+            <a:ext cx="548640" cy="173736"/>
           </a:xfrm>
           <a:prstGeom prst="rect">
             <a:avLst/>
@@ -48075,14 +48196,14 @@
       </p:sp>
       <p:sp>
         <p:nvSpPr>
-          <p:cNvPr id="51" name="Text 48"/>
-          <p:cNvSpPr txBox="1"/>
-          <p:nvPr/>
-        </p:nvSpPr>
-        <p:spPr>
-          <a:xfrm>
-            <a:off x="9921240" y="4886554"/>
-            <a:ext cx="685800" cy="173736"/>
+          <p:cNvPr id="54" name="Text 51"/>
+          <p:cNvSpPr txBox="1"/>
+          <p:nvPr/>
+        </p:nvSpPr>
+        <p:spPr>
+          <a:xfrm>
+            <a:off x="8705088" y="4886554"/>
+            <a:ext cx="548640" cy="173736"/>
           </a:xfrm>
           <a:prstGeom prst="rect">
             <a:avLst/>
@@ -48114,14 +48235,14 @@
       </p:sp>
       <p:sp>
         <p:nvSpPr>
-          <p:cNvPr id="52" name="Text 49"/>
-          <p:cNvSpPr txBox="1"/>
-          <p:nvPr/>
-        </p:nvSpPr>
-        <p:spPr>
-          <a:xfrm>
-            <a:off x="10652760" y="4886554"/>
-            <a:ext cx="457200" cy="173736"/>
+          <p:cNvPr id="55" name="Text 52"/>
+          <p:cNvSpPr txBox="1"/>
+          <p:nvPr/>
+        </p:nvSpPr>
+        <p:spPr>
+          <a:xfrm>
+            <a:off x="9281160" y="4886554"/>
+            <a:ext cx="365760" cy="173736"/>
           </a:xfrm>
           <a:prstGeom prst="rect">
             <a:avLst/>
@@ -48153,14 +48274,55 @@
       </p:sp>
       <p:sp>
         <p:nvSpPr>
-          <p:cNvPr id="53" name="Text 50"/>
-          <p:cNvSpPr txBox="1"/>
-          <p:nvPr/>
-        </p:nvSpPr>
-        <p:spPr>
-          <a:xfrm>
-            <a:off x="11155680" y="4886554"/>
-            <a:ext cx="384048" cy="173736"/>
+          <p:cNvPr id="56" name="Text 53"/>
+          <p:cNvSpPr txBox="1"/>
+          <p:nvPr/>
+        </p:nvSpPr>
+        <p:spPr>
+          <a:xfrm>
+            <a:off x="9765792" y="4886554"/>
+            <a:ext cx="1664208" cy="173736"/>
+          </a:xfrm>
+          <a:prstGeom prst="rect">
+            <a:avLst/>
+          </a:prstGeom>
+          <a:noFill/>
+          <a:ln/>
+        </p:spPr>
+        <p:txBody>
+          <a:bodyPr wrap="square" lIns="0" tIns="0" rIns="0" bIns="0" rtlCol="0" anchor="ctr">
+            <a:normAutofit/>
+          </a:bodyPr>
+          <a:lstStyle/>
+          <a:p>
+            <a:pPr indent="0" marL="0">
+              <a:buNone/>
+            </a:pPr>
+            <a:r>
+              <a:rPr lang="en-US" sz="680" dirty="0">
+                <a:solidFill>
+                  <a:srgbClr val="12293A"/>
+                </a:solidFill>
+                <a:latin typeface="Poppins" pitchFamily="34" charset="0"/>
+                <a:ea typeface="Poppins" pitchFamily="34" charset="-122"/>
+                <a:cs typeface="Poppins" pitchFamily="34" charset="-120"/>
+              </a:rPr>
+              <a:t>Done last qtr · to close out</a:t>
+            </a:r>
+            <a:endParaRPr lang="en-US" sz="680" dirty="0"/>
+          </a:p>
+        </p:txBody>
+      </p:sp>
+      <p:sp>
+        <p:nvSpPr>
+          <p:cNvPr id="57" name="Text 54"/>
+          <p:cNvSpPr txBox="1"/>
+          <p:nvPr/>
+        </p:nvSpPr>
+        <p:spPr>
+          <a:xfrm>
+            <a:off x="11448288" y="4886554"/>
+            <a:ext cx="182880" cy="173736"/>
           </a:xfrm>
           <a:prstGeom prst="rect">
             <a:avLst/>
@@ -48181,7 +48343,7 @@
       </p:sp>
       <p:sp>
         <p:nvSpPr>
-          <p:cNvPr id="54" name="Text 51"/>
+          <p:cNvPr id="58" name="Text 55"/>
           <p:cNvSpPr txBox="1"/>
           <p:nvPr/>
         </p:nvSpPr>
@@ -48220,14 +48382,14 @@
       </p:sp>
       <p:sp>
         <p:nvSpPr>
-          <p:cNvPr id="55" name="Text 52"/>
+          <p:cNvPr id="59" name="Text 56"/>
           <p:cNvSpPr txBox="1"/>
           <p:nvPr/>
         </p:nvSpPr>
         <p:spPr>
           <a:xfrm>
             <a:off x="6748272" y="5062118"/>
-            <a:ext cx="2286000" cy="173736"/>
+            <a:ext cx="1371600" cy="173736"/>
           </a:xfrm>
           <a:prstGeom prst="rect">
             <a:avLst/>
@@ -48259,14 +48421,14 @@
       </p:sp>
       <p:sp>
         <p:nvSpPr>
-          <p:cNvPr id="56" name="Text 53"/>
-          <p:cNvSpPr txBox="1"/>
-          <p:nvPr/>
-        </p:nvSpPr>
-        <p:spPr>
-          <a:xfrm>
-            <a:off x="9052560" y="5062118"/>
-            <a:ext cx="822960" cy="173736"/>
+          <p:cNvPr id="60" name="Text 57"/>
+          <p:cNvSpPr txBox="1"/>
+          <p:nvPr/>
+        </p:nvSpPr>
+        <p:spPr>
+          <a:xfrm>
+            <a:off x="8138160" y="5062118"/>
+            <a:ext cx="548640" cy="173736"/>
           </a:xfrm>
           <a:prstGeom prst="rect">
             <a:avLst/>
@@ -48298,14 +48460,14 @@
       </p:sp>
       <p:sp>
         <p:nvSpPr>
-          <p:cNvPr id="57" name="Text 54"/>
-          <p:cNvSpPr txBox="1"/>
-          <p:nvPr/>
-        </p:nvSpPr>
-        <p:spPr>
-          <a:xfrm>
-            <a:off x="9921240" y="5062118"/>
-            <a:ext cx="685800" cy="173736"/>
+          <p:cNvPr id="61" name="Text 58"/>
+          <p:cNvSpPr txBox="1"/>
+          <p:nvPr/>
+        </p:nvSpPr>
+        <p:spPr>
+          <a:xfrm>
+            <a:off x="8705088" y="5062118"/>
+            <a:ext cx="548640" cy="173736"/>
           </a:xfrm>
           <a:prstGeom prst="rect">
             <a:avLst/>
@@ -48337,14 +48499,14 @@
       </p:sp>
       <p:sp>
         <p:nvSpPr>
-          <p:cNvPr id="58" name="Text 55"/>
-          <p:cNvSpPr txBox="1"/>
-          <p:nvPr/>
-        </p:nvSpPr>
-        <p:spPr>
-          <a:xfrm>
-            <a:off x="10652760" y="5062118"/>
-            <a:ext cx="457200" cy="173736"/>
+          <p:cNvPr id="62" name="Text 59"/>
+          <p:cNvSpPr txBox="1"/>
+          <p:nvPr/>
+        </p:nvSpPr>
+        <p:spPr>
+          <a:xfrm>
+            <a:off x="9281160" y="5062118"/>
+            <a:ext cx="365760" cy="173736"/>
           </a:xfrm>
           <a:prstGeom prst="rect">
             <a:avLst/>
@@ -48376,14 +48538,55 @@
       </p:sp>
       <p:sp>
         <p:nvSpPr>
-          <p:cNvPr id="59" name="Text 56"/>
-          <p:cNvSpPr txBox="1"/>
-          <p:nvPr/>
-        </p:nvSpPr>
-        <p:spPr>
-          <a:xfrm>
-            <a:off x="11155680" y="5062118"/>
-            <a:ext cx="384048" cy="173736"/>
+          <p:cNvPr id="63" name="Text 60"/>
+          <p:cNvSpPr txBox="1"/>
+          <p:nvPr/>
+        </p:nvSpPr>
+        <p:spPr>
+          <a:xfrm>
+            <a:off x="9765792" y="5062118"/>
+            <a:ext cx="1664208" cy="173736"/>
+          </a:xfrm>
+          <a:prstGeom prst="rect">
+            <a:avLst/>
+          </a:prstGeom>
+          <a:noFill/>
+          <a:ln/>
+        </p:spPr>
+        <p:txBody>
+          <a:bodyPr wrap="square" lIns="0" tIns="0" rIns="0" bIns="0" rtlCol="0" anchor="ctr">
+            <a:normAutofit/>
+          </a:bodyPr>
+          <a:lstStyle/>
+          <a:p>
+            <a:pPr indent="0" marL="0">
+              <a:buNone/>
+            </a:pPr>
+            <a:r>
+              <a:rPr lang="en-US" sz="680" dirty="0">
+                <a:solidFill>
+                  <a:srgbClr val="12293A"/>
+                </a:solidFill>
+                <a:latin typeface="Poppins" pitchFamily="34" charset="0"/>
+                <a:ea typeface="Poppins" pitchFamily="34" charset="-122"/>
+                <a:cs typeface="Poppins" pitchFamily="34" charset="-120"/>
+              </a:rPr>
+              <a:t>Build late Nov · live ~23 Nov</a:t>
+            </a:r>
+            <a:endParaRPr lang="en-US" sz="680" dirty="0"/>
+          </a:p>
+        </p:txBody>
+      </p:sp>
+      <p:sp>
+        <p:nvSpPr>
+          <p:cNvPr id="64" name="Text 61"/>
+          <p:cNvSpPr txBox="1"/>
+          <p:nvPr/>
+        </p:nvSpPr>
+        <p:spPr>
+          <a:xfrm>
+            <a:off x="11448288" y="5062118"/>
+            <a:ext cx="182880" cy="173736"/>
           </a:xfrm>
           <a:prstGeom prst="rect">
             <a:avLst/>
@@ -48404,7 +48607,7 @@
       </p:sp>
       <p:sp>
         <p:nvSpPr>
-          <p:cNvPr id="60" name="Text 57"/>
+          <p:cNvPr id="65" name="Text 62"/>
           <p:cNvSpPr txBox="1"/>
           <p:nvPr/>
         </p:nvSpPr>
@@ -48443,14 +48646,14 @@
       </p:sp>
       <p:sp>
         <p:nvSpPr>
-          <p:cNvPr id="61" name="Text 58"/>
+          <p:cNvPr id="66" name="Text 63"/>
           <p:cNvSpPr txBox="1"/>
           <p:nvPr/>
         </p:nvSpPr>
         <p:spPr>
           <a:xfrm>
             <a:off x="6748272" y="5237683"/>
-            <a:ext cx="2286000" cy="173736"/>
+            <a:ext cx="1371600" cy="173736"/>
           </a:xfrm>
           <a:prstGeom prst="rect">
             <a:avLst/>
@@ -48482,14 +48685,14 @@
       </p:sp>
       <p:sp>
         <p:nvSpPr>
-          <p:cNvPr id="62" name="Text 59"/>
-          <p:cNvSpPr txBox="1"/>
-          <p:nvPr/>
-        </p:nvSpPr>
-        <p:spPr>
-          <a:xfrm>
-            <a:off x="9052560" y="5237683"/>
-            <a:ext cx="822960" cy="173736"/>
+          <p:cNvPr id="67" name="Text 64"/>
+          <p:cNvSpPr txBox="1"/>
+          <p:nvPr/>
+        </p:nvSpPr>
+        <p:spPr>
+          <a:xfrm>
+            <a:off x="8138160" y="5237683"/>
+            <a:ext cx="548640" cy="173736"/>
           </a:xfrm>
           <a:prstGeom prst="rect">
             <a:avLst/>
@@ -48521,14 +48724,14 @@
       </p:sp>
       <p:sp>
         <p:nvSpPr>
-          <p:cNvPr id="63" name="Text 60"/>
-          <p:cNvSpPr txBox="1"/>
-          <p:nvPr/>
-        </p:nvSpPr>
-        <p:spPr>
-          <a:xfrm>
-            <a:off x="9921240" y="5237683"/>
-            <a:ext cx="685800" cy="173736"/>
+          <p:cNvPr id="68" name="Text 65"/>
+          <p:cNvSpPr txBox="1"/>
+          <p:nvPr/>
+        </p:nvSpPr>
+        <p:spPr>
+          <a:xfrm>
+            <a:off x="8705088" y="5237683"/>
+            <a:ext cx="548640" cy="173736"/>
           </a:xfrm>
           <a:prstGeom prst="rect">
             <a:avLst/>
@@ -48560,14 +48763,14 @@
       </p:sp>
       <p:sp>
         <p:nvSpPr>
-          <p:cNvPr id="64" name="Text 61"/>
-          <p:cNvSpPr txBox="1"/>
-          <p:nvPr/>
-        </p:nvSpPr>
-        <p:spPr>
-          <a:xfrm>
-            <a:off x="10652760" y="5237683"/>
-            <a:ext cx="457200" cy="173736"/>
+          <p:cNvPr id="69" name="Text 66"/>
+          <p:cNvSpPr txBox="1"/>
+          <p:nvPr/>
+        </p:nvSpPr>
+        <p:spPr>
+          <a:xfrm>
+            <a:off x="9281160" y="5237683"/>
+            <a:ext cx="365760" cy="173736"/>
           </a:xfrm>
           <a:prstGeom prst="rect">
             <a:avLst/>
@@ -48599,14 +48802,55 @@
       </p:sp>
       <p:sp>
         <p:nvSpPr>
-          <p:cNvPr id="65" name="Text 62"/>
-          <p:cNvSpPr txBox="1"/>
-          <p:nvPr/>
-        </p:nvSpPr>
-        <p:spPr>
-          <a:xfrm>
-            <a:off x="11155680" y="5237683"/>
-            <a:ext cx="384048" cy="173736"/>
+          <p:cNvPr id="70" name="Text 67"/>
+          <p:cNvSpPr txBox="1"/>
+          <p:nvPr/>
+        </p:nvSpPr>
+        <p:spPr>
+          <a:xfrm>
+            <a:off x="9765792" y="5237683"/>
+            <a:ext cx="1664208" cy="173736"/>
+          </a:xfrm>
+          <a:prstGeom prst="rect">
+            <a:avLst/>
+          </a:prstGeom>
+          <a:noFill/>
+          <a:ln/>
+        </p:spPr>
+        <p:txBody>
+          <a:bodyPr wrap="square" lIns="0" tIns="0" rIns="0" bIns="0" rtlCol="0" anchor="ctr">
+            <a:normAutofit/>
+          </a:bodyPr>
+          <a:lstStyle/>
+          <a:p>
+            <a:pPr indent="0" marL="0">
+              <a:buNone/>
+            </a:pPr>
+            <a:r>
+              <a:rPr lang="en-US" sz="680" dirty="0">
+                <a:solidFill>
+                  <a:srgbClr val="12293A"/>
+                </a:solidFill>
+                <a:latin typeface="Poppins" pitchFamily="34" charset="0"/>
+                <a:ea typeface="Poppins" pitchFamily="34" charset="-122"/>
+                <a:cs typeface="Poppins" pitchFamily="34" charset="-120"/>
+              </a:rPr>
+              <a:t>Venue still building · ~Dec</a:t>
+            </a:r>
+            <a:endParaRPr lang="en-US" sz="680" dirty="0"/>
+          </a:p>
+        </p:txBody>
+      </p:sp>
+      <p:sp>
+        <p:nvSpPr>
+          <p:cNvPr id="71" name="Text 68"/>
+          <p:cNvSpPr txBox="1"/>
+          <p:nvPr/>
+        </p:nvSpPr>
+        <p:spPr>
+          <a:xfrm>
+            <a:off x="11448288" y="5237683"/>
+            <a:ext cx="182880" cy="173736"/>
           </a:xfrm>
           <a:prstGeom prst="rect">
             <a:avLst/>
@@ -48627,7 +48871,7 @@
       </p:sp>
       <p:sp>
         <p:nvSpPr>
-          <p:cNvPr id="66" name="Text 63"/>
+          <p:cNvPr id="72" name="Text 69"/>
           <p:cNvSpPr txBox="1"/>
           <p:nvPr/>
         </p:nvSpPr>
@@ -48666,14 +48910,14 @@
       </p:sp>
       <p:sp>
         <p:nvSpPr>
-          <p:cNvPr id="67" name="Text 64"/>
+          <p:cNvPr id="73" name="Text 70"/>
           <p:cNvSpPr txBox="1"/>
           <p:nvPr/>
         </p:nvSpPr>
         <p:spPr>
           <a:xfrm>
             <a:off x="6748272" y="5413248"/>
-            <a:ext cx="2286000" cy="173736"/>
+            <a:ext cx="1371600" cy="173736"/>
           </a:xfrm>
           <a:prstGeom prst="rect">
             <a:avLst/>
@@ -48705,14 +48949,14 @@
       </p:sp>
       <p:sp>
         <p:nvSpPr>
-          <p:cNvPr id="68" name="Text 65"/>
-          <p:cNvSpPr txBox="1"/>
-          <p:nvPr/>
-        </p:nvSpPr>
-        <p:spPr>
-          <a:xfrm>
-            <a:off x="9052560" y="5413248"/>
-            <a:ext cx="822960" cy="173736"/>
+          <p:cNvPr id="74" name="Text 71"/>
+          <p:cNvSpPr txBox="1"/>
+          <p:nvPr/>
+        </p:nvSpPr>
+        <p:spPr>
+          <a:xfrm>
+            <a:off x="8138160" y="5413248"/>
+            <a:ext cx="548640" cy="173736"/>
           </a:xfrm>
           <a:prstGeom prst="rect">
             <a:avLst/>
@@ -48744,14 +48988,14 @@
       </p:sp>
       <p:sp>
         <p:nvSpPr>
-          <p:cNvPr id="69" name="Text 66"/>
-          <p:cNvSpPr txBox="1"/>
-          <p:nvPr/>
-        </p:nvSpPr>
-        <p:spPr>
-          <a:xfrm>
-            <a:off x="9921240" y="5413248"/>
-            <a:ext cx="685800" cy="173736"/>
+          <p:cNvPr id="75" name="Text 72"/>
+          <p:cNvSpPr txBox="1"/>
+          <p:nvPr/>
+        </p:nvSpPr>
+        <p:spPr>
+          <a:xfrm>
+            <a:off x="8705088" y="5413248"/>
+            <a:ext cx="548640" cy="173736"/>
           </a:xfrm>
           <a:prstGeom prst="rect">
             <a:avLst/>
@@ -48783,14 +49027,14 @@
       </p:sp>
       <p:sp>
         <p:nvSpPr>
-          <p:cNvPr id="70" name="Text 67"/>
-          <p:cNvSpPr txBox="1"/>
-          <p:nvPr/>
-        </p:nvSpPr>
-        <p:spPr>
-          <a:xfrm>
-            <a:off x="10652760" y="5413248"/>
-            <a:ext cx="457200" cy="173736"/>
+          <p:cNvPr id="76" name="Text 73"/>
+          <p:cNvSpPr txBox="1"/>
+          <p:nvPr/>
+        </p:nvSpPr>
+        <p:spPr>
+          <a:xfrm>
+            <a:off x="9281160" y="5413248"/>
+            <a:ext cx="365760" cy="173736"/>
           </a:xfrm>
           <a:prstGeom prst="rect">
             <a:avLst/>
@@ -48822,14 +49066,55 @@
       </p:sp>
       <p:sp>
         <p:nvSpPr>
-          <p:cNvPr id="71" name="Text 68"/>
-          <p:cNvSpPr txBox="1"/>
-          <p:nvPr/>
-        </p:nvSpPr>
-        <p:spPr>
-          <a:xfrm>
-            <a:off x="11155680" y="5413248"/>
-            <a:ext cx="384048" cy="173736"/>
+          <p:cNvPr id="77" name="Text 74"/>
+          <p:cNvSpPr txBox="1"/>
+          <p:nvPr/>
+        </p:nvSpPr>
+        <p:spPr>
+          <a:xfrm>
+            <a:off x="9765792" y="5413248"/>
+            <a:ext cx="1664208" cy="173736"/>
+          </a:xfrm>
+          <a:prstGeom prst="rect">
+            <a:avLst/>
+          </a:prstGeom>
+          <a:noFill/>
+          <a:ln/>
+        </p:spPr>
+        <p:txBody>
+          <a:bodyPr wrap="square" lIns="0" tIns="0" rIns="0" bIns="0" rtlCol="0" anchor="ctr">
+            <a:normAutofit/>
+          </a:bodyPr>
+          <a:lstStyle/>
+          <a:p>
+            <a:pPr indent="0" marL="0">
+              <a:buNone/>
+            </a:pPr>
+            <a:r>
+              <a:rPr lang="en-US" sz="680" dirty="0">
+                <a:solidFill>
+                  <a:srgbClr val="8FA1AC"/>
+                </a:solidFill>
+                <a:latin typeface="Poppins" pitchFamily="34" charset="0"/>
+                <a:ea typeface="Poppins" pitchFamily="34" charset="-122"/>
+                <a:cs typeface="Poppins" pitchFamily="34" charset="-120"/>
+              </a:rPr>
+              <a:t>—</a:t>
+            </a:r>
+            <a:endParaRPr lang="en-US" sz="680" dirty="0"/>
+          </a:p>
+        </p:txBody>
+      </p:sp>
+      <p:sp>
+        <p:nvSpPr>
+          <p:cNvPr id="78" name="Text 75"/>
+          <p:cNvSpPr txBox="1"/>
+          <p:nvPr/>
+        </p:nvSpPr>
+        <p:spPr>
+          <a:xfrm>
+            <a:off x="11448288" y="5413248"/>
+            <a:ext cx="182880" cy="173736"/>
           </a:xfrm>
           <a:prstGeom prst="rect">
             <a:avLst/>
@@ -48850,7 +49135,7 @@
       </p:sp>
       <p:sp>
         <p:nvSpPr>
-          <p:cNvPr id="72" name="Text 69"/>
+          <p:cNvPr id="79" name="Text 76"/>
           <p:cNvSpPr txBox="1"/>
           <p:nvPr/>
         </p:nvSpPr>
@@ -48889,14 +49174,14 @@
       </p:sp>
       <p:sp>
         <p:nvSpPr>
-          <p:cNvPr id="73" name="Text 70"/>
+          <p:cNvPr id="80" name="Text 77"/>
           <p:cNvSpPr txBox="1"/>
           <p:nvPr/>
         </p:nvSpPr>
         <p:spPr>
           <a:xfrm>
             <a:off x="6748272" y="5588813"/>
-            <a:ext cx="2286000" cy="173736"/>
+            <a:ext cx="1371600" cy="173736"/>
           </a:xfrm>
           <a:prstGeom prst="rect">
             <a:avLst/>
@@ -48928,14 +49213,14 @@
       </p:sp>
       <p:sp>
         <p:nvSpPr>
-          <p:cNvPr id="74" name="Text 71"/>
-          <p:cNvSpPr txBox="1"/>
-          <p:nvPr/>
-        </p:nvSpPr>
-        <p:spPr>
-          <a:xfrm>
-            <a:off x="9052560" y="5588813"/>
-            <a:ext cx="822960" cy="173736"/>
+          <p:cNvPr id="81" name="Text 78"/>
+          <p:cNvSpPr txBox="1"/>
+          <p:nvPr/>
+        </p:nvSpPr>
+        <p:spPr>
+          <a:xfrm>
+            <a:off x="8138160" y="5588813"/>
+            <a:ext cx="548640" cy="173736"/>
           </a:xfrm>
           <a:prstGeom prst="rect">
             <a:avLst/>
@@ -48967,14 +49252,14 @@
       </p:sp>
       <p:sp>
         <p:nvSpPr>
-          <p:cNvPr id="75" name="Text 72"/>
-          <p:cNvSpPr txBox="1"/>
-          <p:nvPr/>
-        </p:nvSpPr>
-        <p:spPr>
-          <a:xfrm>
-            <a:off x="9921240" y="5588813"/>
-            <a:ext cx="685800" cy="173736"/>
+          <p:cNvPr id="82" name="Text 79"/>
+          <p:cNvSpPr txBox="1"/>
+          <p:nvPr/>
+        </p:nvSpPr>
+        <p:spPr>
+          <a:xfrm>
+            <a:off x="8705088" y="5588813"/>
+            <a:ext cx="548640" cy="173736"/>
           </a:xfrm>
           <a:prstGeom prst="rect">
             <a:avLst/>
@@ -49006,14 +49291,14 @@
       </p:sp>
       <p:sp>
         <p:nvSpPr>
-          <p:cNvPr id="76" name="Text 73"/>
-          <p:cNvSpPr txBox="1"/>
-          <p:nvPr/>
-        </p:nvSpPr>
-        <p:spPr>
-          <a:xfrm>
-            <a:off x="10652760" y="5588813"/>
-            <a:ext cx="457200" cy="173736"/>
+          <p:cNvPr id="83" name="Text 80"/>
+          <p:cNvSpPr txBox="1"/>
+          <p:nvPr/>
+        </p:nvSpPr>
+        <p:spPr>
+          <a:xfrm>
+            <a:off x="9281160" y="5588813"/>
+            <a:ext cx="365760" cy="173736"/>
           </a:xfrm>
           <a:prstGeom prst="rect">
             <a:avLst/>
@@ -49045,14 +49330,55 @@
       </p:sp>
       <p:sp>
         <p:nvSpPr>
-          <p:cNvPr id="77" name="Text 74"/>
-          <p:cNvSpPr txBox="1"/>
-          <p:nvPr/>
-        </p:nvSpPr>
-        <p:spPr>
-          <a:xfrm>
-            <a:off x="11155680" y="5588813"/>
-            <a:ext cx="384048" cy="173736"/>
+          <p:cNvPr id="84" name="Text 81"/>
+          <p:cNvSpPr txBox="1"/>
+          <p:nvPr/>
+        </p:nvSpPr>
+        <p:spPr>
+          <a:xfrm>
+            <a:off x="9765792" y="5588813"/>
+            <a:ext cx="1664208" cy="173736"/>
+          </a:xfrm>
+          <a:prstGeom prst="rect">
+            <a:avLst/>
+          </a:prstGeom>
+          <a:noFill/>
+          <a:ln/>
+        </p:spPr>
+        <p:txBody>
+          <a:bodyPr wrap="square" lIns="0" tIns="0" rIns="0" bIns="0" rtlCol="0" anchor="ctr">
+            <a:normAutofit/>
+          </a:bodyPr>
+          <a:lstStyle/>
+          <a:p>
+            <a:pPr indent="0" marL="0">
+              <a:buNone/>
+            </a:pPr>
+            <a:r>
+              <a:rPr lang="en-US" sz="680" dirty="0">
+                <a:solidFill>
+                  <a:srgbClr val="8FA1AC"/>
+                </a:solidFill>
+                <a:latin typeface="Poppins" pitchFamily="34" charset="0"/>
+                <a:ea typeface="Poppins" pitchFamily="34" charset="-122"/>
+                <a:cs typeface="Poppins" pitchFamily="34" charset="-120"/>
+              </a:rPr>
+              <a:t>—</a:t>
+            </a:r>
+            <a:endParaRPr lang="en-US" sz="680" dirty="0"/>
+          </a:p>
+        </p:txBody>
+      </p:sp>
+      <p:sp>
+        <p:nvSpPr>
+          <p:cNvPr id="85" name="Text 82"/>
+          <p:cNvSpPr txBox="1"/>
+          <p:nvPr/>
+        </p:nvSpPr>
+        <p:spPr>
+          <a:xfrm>
+            <a:off x="11448288" y="5588813"/>
+            <a:ext cx="182880" cy="173736"/>
           </a:xfrm>
           <a:prstGeom prst="rect">
             <a:avLst/>
@@ -49073,7 +49399,7 @@
       </p:sp>
       <p:sp>
         <p:nvSpPr>
-          <p:cNvPr id="78" name="Text 75"/>
+          <p:cNvPr id="86" name="Text 83"/>
           <p:cNvSpPr txBox="1"/>
           <p:nvPr/>
         </p:nvSpPr>
@@ -49112,14 +49438,14 @@
       </p:sp>
       <p:sp>
         <p:nvSpPr>
-          <p:cNvPr id="79" name="Text 76"/>
+          <p:cNvPr id="87" name="Text 84"/>
           <p:cNvSpPr txBox="1"/>
           <p:nvPr/>
         </p:nvSpPr>
         <p:spPr>
           <a:xfrm>
             <a:off x="6748272" y="5764378"/>
-            <a:ext cx="2286000" cy="173736"/>
+            <a:ext cx="1371600" cy="173736"/>
           </a:xfrm>
           <a:prstGeom prst="rect">
             <a:avLst/>
@@ -49151,14 +49477,14 @@
       </p:sp>
       <p:sp>
         <p:nvSpPr>
-          <p:cNvPr id="80" name="Text 77"/>
-          <p:cNvSpPr txBox="1"/>
-          <p:nvPr/>
-        </p:nvSpPr>
-        <p:spPr>
-          <a:xfrm>
-            <a:off x="9052560" y="5764378"/>
-            <a:ext cx="822960" cy="173736"/>
+          <p:cNvPr id="88" name="Text 85"/>
+          <p:cNvSpPr txBox="1"/>
+          <p:nvPr/>
+        </p:nvSpPr>
+        <p:spPr>
+          <a:xfrm>
+            <a:off x="8138160" y="5764378"/>
+            <a:ext cx="548640" cy="173736"/>
           </a:xfrm>
           <a:prstGeom prst="rect">
             <a:avLst/>
@@ -49190,14 +49516,14 @@
       </p:sp>
       <p:sp>
         <p:nvSpPr>
-          <p:cNvPr id="81" name="Text 78"/>
-          <p:cNvSpPr txBox="1"/>
-          <p:nvPr/>
-        </p:nvSpPr>
-        <p:spPr>
-          <a:xfrm>
-            <a:off x="9921240" y="5764378"/>
-            <a:ext cx="685800" cy="173736"/>
+          <p:cNvPr id="89" name="Text 86"/>
+          <p:cNvSpPr txBox="1"/>
+          <p:nvPr/>
+        </p:nvSpPr>
+        <p:spPr>
+          <a:xfrm>
+            <a:off x="8705088" y="5764378"/>
+            <a:ext cx="548640" cy="173736"/>
           </a:xfrm>
           <a:prstGeom prst="rect">
             <a:avLst/>
@@ -49229,14 +49555,14 @@
       </p:sp>
       <p:sp>
         <p:nvSpPr>
-          <p:cNvPr id="82" name="Text 79"/>
-          <p:cNvSpPr txBox="1"/>
-          <p:nvPr/>
-        </p:nvSpPr>
-        <p:spPr>
-          <a:xfrm>
-            <a:off x="10652760" y="5764378"/>
-            <a:ext cx="457200" cy="173736"/>
+          <p:cNvPr id="90" name="Text 87"/>
+          <p:cNvSpPr txBox="1"/>
+          <p:nvPr/>
+        </p:nvSpPr>
+        <p:spPr>
+          <a:xfrm>
+            <a:off x="9281160" y="5764378"/>
+            <a:ext cx="365760" cy="173736"/>
           </a:xfrm>
           <a:prstGeom prst="rect">
             <a:avLst/>
@@ -49268,14 +49594,55 @@
       </p:sp>
       <p:sp>
         <p:nvSpPr>
-          <p:cNvPr id="83" name="Text 80"/>
-          <p:cNvSpPr txBox="1"/>
-          <p:nvPr/>
-        </p:nvSpPr>
-        <p:spPr>
-          <a:xfrm>
-            <a:off x="11155680" y="5764378"/>
-            <a:ext cx="384048" cy="173736"/>
+          <p:cNvPr id="91" name="Text 88"/>
+          <p:cNvSpPr txBox="1"/>
+          <p:nvPr/>
+        </p:nvSpPr>
+        <p:spPr>
+          <a:xfrm>
+            <a:off x="9765792" y="5764378"/>
+            <a:ext cx="1664208" cy="173736"/>
+          </a:xfrm>
+          <a:prstGeom prst="rect">
+            <a:avLst/>
+          </a:prstGeom>
+          <a:noFill/>
+          <a:ln/>
+        </p:spPr>
+        <p:txBody>
+          <a:bodyPr wrap="square" lIns="0" tIns="0" rIns="0" bIns="0" rtlCol="0" anchor="ctr">
+            <a:normAutofit/>
+          </a:bodyPr>
+          <a:lstStyle/>
+          <a:p>
+            <a:pPr indent="0" marL="0">
+              <a:buNone/>
+            </a:pPr>
+            <a:r>
+              <a:rPr lang="en-US" sz="680" dirty="0">
+                <a:solidFill>
+                  <a:srgbClr val="8FA1AC"/>
+                </a:solidFill>
+                <a:latin typeface="Poppins" pitchFamily="34" charset="0"/>
+                <a:ea typeface="Poppins" pitchFamily="34" charset="-122"/>
+                <a:cs typeface="Poppins" pitchFamily="34" charset="-120"/>
+              </a:rPr>
+              <a:t>—</a:t>
+            </a:r>
+            <a:endParaRPr lang="en-US" sz="680" dirty="0"/>
+          </a:p>
+        </p:txBody>
+      </p:sp>
+      <p:sp>
+        <p:nvSpPr>
+          <p:cNvPr id="92" name="Text 89"/>
+          <p:cNvSpPr txBox="1"/>
+          <p:nvPr/>
+        </p:nvSpPr>
+        <p:spPr>
+          <a:xfrm>
+            <a:off x="11448288" y="5764378"/>
+            <a:ext cx="182880" cy="173736"/>
           </a:xfrm>
           <a:prstGeom prst="rect">
             <a:avLst/>
@@ -49296,7 +49663,7 @@
       </p:sp>
       <p:sp>
         <p:nvSpPr>
-          <p:cNvPr id="84" name="Text 81"/>
+          <p:cNvPr id="93" name="Text 90"/>
           <p:cNvSpPr txBox="1"/>
           <p:nvPr/>
         </p:nvSpPr>
@@ -49335,14 +49702,14 @@
       </p:sp>
       <p:sp>
         <p:nvSpPr>
-          <p:cNvPr id="85" name="Text 82"/>
+          <p:cNvPr id="94" name="Text 91"/>
           <p:cNvSpPr txBox="1"/>
           <p:nvPr/>
         </p:nvSpPr>
         <p:spPr>
           <a:xfrm>
             <a:off x="6748272" y="5939942"/>
-            <a:ext cx="2286000" cy="173736"/>
+            <a:ext cx="1371600" cy="173736"/>
           </a:xfrm>
           <a:prstGeom prst="rect">
             <a:avLst/>
@@ -49374,14 +49741,14 @@
       </p:sp>
       <p:sp>
         <p:nvSpPr>
-          <p:cNvPr id="86" name="Text 83"/>
-          <p:cNvSpPr txBox="1"/>
-          <p:nvPr/>
-        </p:nvSpPr>
-        <p:spPr>
-          <a:xfrm>
-            <a:off x="9052560" y="5939942"/>
-            <a:ext cx="822960" cy="173736"/>
+          <p:cNvPr id="95" name="Text 92"/>
+          <p:cNvSpPr txBox="1"/>
+          <p:nvPr/>
+        </p:nvSpPr>
+        <p:spPr>
+          <a:xfrm>
+            <a:off x="8138160" y="5939942"/>
+            <a:ext cx="548640" cy="173736"/>
           </a:xfrm>
           <a:prstGeom prst="rect">
             <a:avLst/>
@@ -49413,14 +49780,14 @@
       </p:sp>
       <p:sp>
         <p:nvSpPr>
-          <p:cNvPr id="87" name="Text 84"/>
-          <p:cNvSpPr txBox="1"/>
-          <p:nvPr/>
-        </p:nvSpPr>
-        <p:spPr>
-          <a:xfrm>
-            <a:off x="9921240" y="5939942"/>
-            <a:ext cx="685800" cy="173736"/>
+          <p:cNvPr id="96" name="Text 93"/>
+          <p:cNvSpPr txBox="1"/>
+          <p:nvPr/>
+        </p:nvSpPr>
+        <p:spPr>
+          <a:xfrm>
+            <a:off x="8705088" y="5939942"/>
+            <a:ext cx="548640" cy="173736"/>
           </a:xfrm>
           <a:prstGeom prst="rect">
             <a:avLst/>
@@ -49452,14 +49819,14 @@
       </p:sp>
       <p:sp>
         <p:nvSpPr>
-          <p:cNvPr id="88" name="Text 85"/>
-          <p:cNvSpPr txBox="1"/>
-          <p:nvPr/>
-        </p:nvSpPr>
-        <p:spPr>
-          <a:xfrm>
-            <a:off x="10652760" y="5939942"/>
-            <a:ext cx="457200" cy="173736"/>
+          <p:cNvPr id="97" name="Text 94"/>
+          <p:cNvSpPr txBox="1"/>
+          <p:nvPr/>
+        </p:nvSpPr>
+        <p:spPr>
+          <a:xfrm>
+            <a:off x="9281160" y="5939942"/>
+            <a:ext cx="365760" cy="173736"/>
           </a:xfrm>
           <a:prstGeom prst="rect">
             <a:avLst/>
@@ -49491,14 +49858,55 @@
       </p:sp>
       <p:sp>
         <p:nvSpPr>
-          <p:cNvPr id="89" name="Text 86"/>
-          <p:cNvSpPr txBox="1"/>
-          <p:nvPr/>
-        </p:nvSpPr>
-        <p:spPr>
-          <a:xfrm>
-            <a:off x="11155680" y="5939942"/>
-            <a:ext cx="384048" cy="173736"/>
+          <p:cNvPr id="98" name="Text 95"/>
+          <p:cNvSpPr txBox="1"/>
+          <p:nvPr/>
+        </p:nvSpPr>
+        <p:spPr>
+          <a:xfrm>
+            <a:off x="9765792" y="5939942"/>
+            <a:ext cx="1664208" cy="173736"/>
+          </a:xfrm>
+          <a:prstGeom prst="rect">
+            <a:avLst/>
+          </a:prstGeom>
+          <a:noFill/>
+          <a:ln/>
+        </p:spPr>
+        <p:txBody>
+          <a:bodyPr wrap="square" lIns="0" tIns="0" rIns="0" bIns="0" rtlCol="0" anchor="ctr">
+            <a:normAutofit/>
+          </a:bodyPr>
+          <a:lstStyle/>
+          <a:p>
+            <a:pPr indent="0" marL="0">
+              <a:buNone/>
+            </a:pPr>
+            <a:r>
+              <a:rPr lang="en-US" sz="680" dirty="0">
+                <a:solidFill>
+                  <a:srgbClr val="8FA1AC"/>
+                </a:solidFill>
+                <a:latin typeface="Poppins" pitchFamily="34" charset="0"/>
+                <a:ea typeface="Poppins" pitchFamily="34" charset="-122"/>
+                <a:cs typeface="Poppins" pitchFamily="34" charset="-120"/>
+              </a:rPr>
+              <a:t>—</a:t>
+            </a:r>
+            <a:endParaRPr lang="en-US" sz="680" dirty="0"/>
+          </a:p>
+        </p:txBody>
+      </p:sp>
+      <p:sp>
+        <p:nvSpPr>
+          <p:cNvPr id="99" name="Text 96"/>
+          <p:cNvSpPr txBox="1"/>
+          <p:nvPr/>
+        </p:nvSpPr>
+        <p:spPr>
+          <a:xfrm>
+            <a:off x="11448288" y="5939942"/>
+            <a:ext cx="182880" cy="173736"/>
           </a:xfrm>
           <a:prstGeom prst="rect">
             <a:avLst/>
@@ -49519,7 +49927,7 @@
       </p:sp>
       <p:sp>
         <p:nvSpPr>
-          <p:cNvPr id="90" name="Text 87"/>
+          <p:cNvPr id="100" name="Text 97"/>
           <p:cNvSpPr txBox="1"/>
           <p:nvPr/>
         </p:nvSpPr>
@@ -49558,14 +49966,14 @@
       </p:sp>
       <p:sp>
         <p:nvSpPr>
-          <p:cNvPr id="91" name="Text 88"/>
+          <p:cNvPr id="101" name="Text 98"/>
           <p:cNvSpPr txBox="1"/>
           <p:nvPr/>
         </p:nvSpPr>
         <p:spPr>
           <a:xfrm>
             <a:off x="6748272" y="6115507"/>
-            <a:ext cx="2286000" cy="173736"/>
+            <a:ext cx="1371600" cy="173736"/>
           </a:xfrm>
           <a:prstGeom prst="rect">
             <a:avLst/>
@@ -49597,14 +50005,14 @@
       </p:sp>
       <p:sp>
         <p:nvSpPr>
-          <p:cNvPr id="92" name="Text 89"/>
-          <p:cNvSpPr txBox="1"/>
-          <p:nvPr/>
-        </p:nvSpPr>
-        <p:spPr>
-          <a:xfrm>
-            <a:off x="9052560" y="6115507"/>
-            <a:ext cx="822960" cy="173736"/>
+          <p:cNvPr id="102" name="Text 99"/>
+          <p:cNvSpPr txBox="1"/>
+          <p:nvPr/>
+        </p:nvSpPr>
+        <p:spPr>
+          <a:xfrm>
+            <a:off x="8138160" y="6115507"/>
+            <a:ext cx="548640" cy="173736"/>
           </a:xfrm>
           <a:prstGeom prst="rect">
             <a:avLst/>
@@ -49636,14 +50044,14 @@
       </p:sp>
       <p:sp>
         <p:nvSpPr>
-          <p:cNvPr id="93" name="Text 90"/>
-          <p:cNvSpPr txBox="1"/>
-          <p:nvPr/>
-        </p:nvSpPr>
-        <p:spPr>
-          <a:xfrm>
-            <a:off x="9921240" y="6115507"/>
-            <a:ext cx="685800" cy="173736"/>
+          <p:cNvPr id="103" name="Text 100"/>
+          <p:cNvSpPr txBox="1"/>
+          <p:nvPr/>
+        </p:nvSpPr>
+        <p:spPr>
+          <a:xfrm>
+            <a:off x="8705088" y="6115507"/>
+            <a:ext cx="548640" cy="173736"/>
           </a:xfrm>
           <a:prstGeom prst="rect">
             <a:avLst/>
@@ -49675,14 +50083,14 @@
       </p:sp>
       <p:sp>
         <p:nvSpPr>
-          <p:cNvPr id="94" name="Text 91"/>
-          <p:cNvSpPr txBox="1"/>
-          <p:nvPr/>
-        </p:nvSpPr>
-        <p:spPr>
-          <a:xfrm>
-            <a:off x="10652760" y="6115507"/>
-            <a:ext cx="457200" cy="173736"/>
+          <p:cNvPr id="104" name="Text 101"/>
+          <p:cNvSpPr txBox="1"/>
+          <p:nvPr/>
+        </p:nvSpPr>
+        <p:spPr>
+          <a:xfrm>
+            <a:off x="9281160" y="6115507"/>
+            <a:ext cx="365760" cy="173736"/>
           </a:xfrm>
           <a:prstGeom prst="rect">
             <a:avLst/>
@@ -49714,14 +50122,55 @@
       </p:sp>
       <p:sp>
         <p:nvSpPr>
-          <p:cNvPr id="95" name="Text 92"/>
-          <p:cNvSpPr txBox="1"/>
-          <p:nvPr/>
-        </p:nvSpPr>
-        <p:spPr>
-          <a:xfrm>
-            <a:off x="11155680" y="6115507"/>
-            <a:ext cx="384048" cy="173736"/>
+          <p:cNvPr id="105" name="Text 102"/>
+          <p:cNvSpPr txBox="1"/>
+          <p:nvPr/>
+        </p:nvSpPr>
+        <p:spPr>
+          <a:xfrm>
+            <a:off x="9765792" y="6115507"/>
+            <a:ext cx="1664208" cy="173736"/>
+          </a:xfrm>
+          <a:prstGeom prst="rect">
+            <a:avLst/>
+          </a:prstGeom>
+          <a:noFill/>
+          <a:ln/>
+        </p:spPr>
+        <p:txBody>
+          <a:bodyPr wrap="square" lIns="0" tIns="0" rIns="0" bIns="0" rtlCol="0" anchor="ctr">
+            <a:normAutofit/>
+          </a:bodyPr>
+          <a:lstStyle/>
+          <a:p>
+            <a:pPr indent="0" marL="0">
+              <a:buNone/>
+            </a:pPr>
+            <a:r>
+              <a:rPr lang="en-US" sz="680" dirty="0">
+                <a:solidFill>
+                  <a:srgbClr val="8FA1AC"/>
+                </a:solidFill>
+                <a:latin typeface="Poppins" pitchFamily="34" charset="0"/>
+                <a:ea typeface="Poppins" pitchFamily="34" charset="-122"/>
+                <a:cs typeface="Poppins" pitchFamily="34" charset="-120"/>
+              </a:rPr>
+              <a:t>—</a:t>
+            </a:r>
+            <a:endParaRPr lang="en-US" sz="680" dirty="0"/>
+          </a:p>
+        </p:txBody>
+      </p:sp>
+      <p:sp>
+        <p:nvSpPr>
+          <p:cNvPr id="106" name="Text 103"/>
+          <p:cNvSpPr txBox="1"/>
+          <p:nvPr/>
+        </p:nvSpPr>
+        <p:spPr>
+          <a:xfrm>
+            <a:off x="11448288" y="6115507"/>
+            <a:ext cx="182880" cy="173736"/>
           </a:xfrm>
           <a:prstGeom prst="rect">
             <a:avLst/>
@@ -49742,7 +50191,7 @@
       </p:sp>
       <p:sp>
         <p:nvSpPr>
-          <p:cNvPr id="96" name="Shape 93"/>
+          <p:cNvPr id="107" name="Shape 104"/>
           <p:cNvSpPr/>
           <p:nvPr/>
         </p:nvSpPr>
@@ -49771,7 +50220,7 @@
       </p:sp>
       <p:sp>
         <p:nvSpPr>
-          <p:cNvPr id="97" name="Text 94"/>
+          <p:cNvPr id="108" name="Text 105"/>
           <p:cNvSpPr txBox="1"/>
           <p:nvPr/>
         </p:nvSpPr>
@@ -49810,7 +50259,7 @@
       </p:sp>
       <p:sp>
         <p:nvSpPr>
-          <p:cNvPr id="98" name="Text 95"/>
+          <p:cNvPr id="109" name="Text 106"/>
           <p:cNvSpPr txBox="1"/>
           <p:nvPr/>
         </p:nvSpPr>
@@ -49968,7 +50417,7 @@
                 <a:ea typeface="Poppins" pitchFamily="34" charset="-122"/>
                 <a:cs typeface="Poppins" pitchFamily="34" charset="-120"/>
               </a:rPr>
-              <a:t>24 of the 86 deals that carried software MRR in 2026 — six of this week's wins have no row yet. Oscars Group is $155k of it.</a:t>
+              <a:t>24 of the 86 deals that carried software MRR in 2026. Oscars Group is $155k of it: 49 sites, build over Dec–Jan for a mid-January go-live. Pier Hotel follows Terminus Morgan (live 26 Oct) around 23 Nov; Iris Pavilion waits on its building.</a:t>
             </a:r>
             <a:endParaRPr lang="en-US" sz="850" dirty="0"/>
           </a:p>
@@ -49985,7 +50434,7 @@
                 <a:ea typeface="Poppins" pitchFamily="34" charset="-122"/>
                 <a:cs typeface="Poppins" pitchFamily="34" charset="-120"/>
               </a:rPr>
-              <a:t>◆ Oscars Group — signed, ~1.5x rollout, held by the old provider's contract terms. AVC new sites are excluded throughout — 17 deals worth $8,759 of 2026 software MRR, parked licences that are not counted in MRR or ARR. Eight more sit below the cut, worth $1.6k/mo.</a:t>
+              <a:t>◆ Oscars Group — across the line per PS Weekly 26 Oct: 49 sites (the HubSpot deal reads 19), build Dec–Jan, go-live mid-January. AVC new sites are excluded throughout — 17 deals worth $8,759 of 2026 software MRR, parked licences that are not counted in MRR or ARR. Eight more sit below the cut, worth $1.6k/mo.</a:t>
             </a:r>
             <a:endParaRPr lang="en-US" sz="850" dirty="0"/>
           </a:p>
@@ -49993,7 +50442,7 @@
       </p:sp>
       <p:sp>
         <p:nvSpPr>
-          <p:cNvPr id="99" name="Text 96"/>
+          <p:cNvPr id="110" name="Text 107"/>
           <p:cNvSpPr txBox="1"/>
           <p:nvPr/>
         </p:nvSpPr>
@@ -50032,7 +50481,7 @@
       </p:sp>
       <p:sp>
         <p:nvSpPr>
-          <p:cNvPr id="100" name="Shape 97"/>
+          <p:cNvPr id="111" name="Shape 108"/>
           <p:cNvSpPr/>
           <p:nvPr/>
         </p:nvSpPr>
@@ -50054,7 +50503,7 @@
       </p:sp>
       <p:sp>
         <p:nvSpPr>
-          <p:cNvPr id="101" name="Text 98"/>
+          <p:cNvPr id="112" name="Text 109"/>
           <p:cNvSpPr txBox="1"/>
           <p:nvPr/>
         </p:nvSpPr>

</xml_diff>

<commit_message>
WC 19 Oct: re-pull AI products, PS and Support from HubSpot; Greg's sick days in PS base
Co-Authored-By: Claude Opus 5.5 <noreply@anthropic.com>
Claude-Session: https://claude.ai/code/session_01Lq5maWicgiSj2RkHzTdcCm
</commit_message>
<xml_diff>
--- a/exec-deck/output/H&L Weekly Update - WC 19 Oct 2026.pptx
+++ b/exec-deck/output/H&L Weekly Update - WC 19 Oct 2026.pptx
@@ -1949,7 +1949,7 @@
                   <c:v>561</c:v>
                 </c:pt>
                 <c:pt idx="24">
-                  <c:v>396</c:v>
+                  <c:v>395</c:v>
                 </c:pt>
               </c:numCache>
             </c:numRef>
@@ -2164,7 +2164,7 @@
                   <c:v>608</c:v>
                 </c:pt>
                 <c:pt idx="24">
-                  <c:v>597</c:v>
+                  <c:v>595</c:v>
                 </c:pt>
               </c:numCache>
             </c:numRef>
@@ -2435,7 +2435,7 @@
                   <c:v>-47</c:v>
                 </c:pt>
                 <c:pt idx="24">
-                  <c:v>-201</c:v>
+                  <c:v>-200</c:v>
                 </c:pt>
               </c:numCache>
             </c:numRef>
@@ -25631,7 +25631,7 @@
                 <a:ea typeface="Poppins" pitchFamily="34" charset="-122"/>
                 <a:cs typeface="Poppins" pitchFamily="34" charset="-120"/>
               </a:rPr>
-              <a:t>billable utilisation 3.7% — 11.5h of 311.6h; 10.5h chargeable, 1.0h non-chargeable; Q4 hidden work 20h = $3,000 unrecognised PS revenue</a:t>
+              <a:t>billable utilisation 4.7% — 13.5h of 288.8h; 10.5h chargeable, 3.0h non-chargeable; Q4 hidden work 22h = $3,300 unrecognised PS revenue</a:t>
             </a:r>
             <a:endParaRPr lang="en-US" sz="900" dirty="0"/>
           </a:p>
@@ -25820,7 +25820,7 @@
                 <a:ea typeface="Poppins" pitchFamily="34" charset="-122"/>
                 <a:cs typeface="Poppins" pitchFamily="34" charset="-120"/>
               </a:rPr>
-              <a:t>inflow 396 vs resolved 597 — backlog 588 → 389, third straight fall; 54 of the closes were one bulk close of September voice tickets</a:t>
+              <a:t>inflow 395 vs resolved 595 — backlog 588 → 389, third straight fall; 54 of the closes were one bulk close of September voice tickets</a:t>
             </a:r>
             <a:endParaRPr lang="en-US" sz="900" dirty="0"/>
           </a:p>
@@ -32278,7 +32278,7 @@
                 <a:ea typeface="Poppins" pitchFamily="34" charset="-122"/>
                 <a:cs typeface="Poppins" pitchFamily="34" charset="-120"/>
               </a:rPr>
-              <a:t>US$2,081</a:t>
+              <a:t>US$1,846</a:t>
             </a:r>
             <a:endParaRPr lang="en-US" sz="2400" dirty="0"/>
           </a:p>
@@ -32317,7 +32317,7 @@
                 <a:ea typeface="Poppins" pitchFamily="34" charset="-122"/>
                 <a:cs typeface="Poppins" pitchFamily="34" charset="-120"/>
               </a:rPr>
-              <a:t>A$2,922 · 32 deals not yet ordered</a:t>
+              <a:t>A$2,592 · 35 deals not yet ordered</a:t>
             </a:r>
             <a:endParaRPr lang="en-US" sz="780" dirty="0"/>
           </a:p>
@@ -32424,7 +32424,7 @@
                 <a:ea typeface="Poppins" pitchFamily="34" charset="-122"/>
                 <a:cs typeface="Poppins" pitchFamily="34" charset="-120"/>
               </a:rPr>
-              <a:t>US$552</a:t>
+              <a:t>US$596</a:t>
             </a:r>
             <a:endParaRPr lang="en-US" sz="2400" dirty="0"/>
           </a:p>
@@ -32463,7 +32463,7 @@
                 <a:ea typeface="Poppins" pitchFamily="34" charset="-122"/>
                 <a:cs typeface="Poppins" pitchFamily="34" charset="-120"/>
               </a:rPr>
-              <a:t>A$775 · 11 deals since 1 Jul</a:t>
+              <a:t>A$837 · 12 deals since 1 Jul</a:t>
             </a:r>
             <a:endParaRPr lang="en-US" sz="780" dirty="0"/>
           </a:p>
@@ -32570,7 +32570,7 @@
                 <a:ea typeface="Poppins" pitchFamily="34" charset="-122"/>
                 <a:cs typeface="Poppins" pitchFamily="34" charset="-120"/>
               </a:rPr>
-              <a:t>US$360</a:t>
+              <a:t>US$595</a:t>
             </a:r>
             <a:endParaRPr lang="en-US" sz="2400" dirty="0"/>
           </a:p>
@@ -32609,7 +32609,7 @@
                 <a:ea typeface="Poppins" pitchFamily="34" charset="-122"/>
                 <a:cs typeface="Poppins" pitchFamily="34" charset="-120"/>
               </a:rPr>
-              <a:t>A$506 · 7 deals since 1 Jul</a:t>
+              <a:t>A$836 · 8 deals since 1 Jul</a:t>
             </a:r>
             <a:endParaRPr lang="en-US" sz="780" dirty="0"/>
           </a:p>
@@ -32716,7 +32716,7 @@
                 <a:ea typeface="Poppins" pitchFamily="34" charset="-122"/>
                 <a:cs typeface="Poppins" pitchFamily="34" charset="-120"/>
               </a:rPr>
-              <a:t>61%</a:t>
+              <a:t>60%</a:t>
             </a:r>
             <a:endParaRPr lang="en-US" sz="2400" dirty="0"/>
           </a:p>
@@ -32755,7 +32755,7 @@
                 <a:ea typeface="Poppins" pitchFamily="34" charset="-122"/>
                 <a:cs typeface="Poppins" pitchFamily="34" charset="-120"/>
               </a:rPr>
-              <a:t>11 placed / 7 lost by count · 60% by value</a:t>
+              <a:t>12 placed / 8 lost by count · 50% by value</a:t>
             </a:r>
             <a:endParaRPr lang="en-US" sz="780" dirty="0"/>
           </a:p>
@@ -32976,7 +32976,7 @@
                 <a:ea typeface="Poppins" pitchFamily="34" charset="-122"/>
                 <a:cs typeface="Poppins" pitchFamily="34" charset="-120"/>
               </a:rPr>
-              <a:t>6 deals</a:t>
+              <a:t>10 deals</a:t>
             </a:r>
             <a:endParaRPr lang="en-US" sz="750" dirty="0"/>
           </a:p>
@@ -33169,7 +33169,7 @@
         <p:spPr>
           <a:xfrm>
             <a:off x="1828800" y="3313176"/>
-            <a:ext cx="2811201" cy="182880"/>
+            <a:ext cx="2047036" cy="182880"/>
           </a:xfrm>
           <a:prstGeom prst="roundRect">
             <a:avLst>
@@ -33215,7 +33215,7 @@
                 <a:ea typeface="Poppins" pitchFamily="34" charset="-122"/>
                 <a:cs typeface="Poppins" pitchFamily="34" charset="-120"/>
               </a:rPr>
-              <a:t>US$865</a:t>
+              <a:t>US$630</a:t>
             </a:r>
             <a:endParaRPr lang="en-US" sz="900" dirty="0"/>
           </a:p>
@@ -33254,7 +33254,7 @@
                 <a:ea typeface="Poppins" pitchFamily="34" charset="-122"/>
                 <a:cs typeface="Poppins" pitchFamily="34" charset="-120"/>
               </a:rPr>
-              <a:t>7 deals</a:t>
+              <a:t>6 deals</a:t>
             </a:r>
             <a:endParaRPr lang="en-US" sz="750" dirty="0"/>
           </a:p>
@@ -33447,7 +33447,7 @@
         <p:spPr>
           <a:xfrm>
             <a:off x="1828800" y="3892296"/>
-            <a:ext cx="1794630" cy="182880"/>
+            <a:ext cx="1938200" cy="182880"/>
           </a:xfrm>
           <a:prstGeom prst="roundRect">
             <a:avLst>
@@ -33493,7 +33493,7 @@
                 <a:ea typeface="Poppins" pitchFamily="34" charset="-122"/>
                 <a:cs typeface="Poppins" pitchFamily="34" charset="-120"/>
               </a:rPr>
-              <a:t>US$552</a:t>
+              <a:t>US$596</a:t>
             </a:r>
             <a:endParaRPr lang="en-US" sz="900" dirty="0"/>
           </a:p>
@@ -33532,7 +33532,7 @@
                 <a:ea typeface="Poppins" pitchFamily="34" charset="-122"/>
                 <a:cs typeface="Poppins" pitchFamily="34" charset="-120"/>
               </a:rPr>
-              <a:t>11 deals</a:t>
+              <a:t>12 deals</a:t>
             </a:r>
             <a:endParaRPr lang="en-US" sz="750" dirty="0"/>
           </a:p>
@@ -33586,7 +33586,7 @@
         <p:spPr>
           <a:xfrm>
             <a:off x="1828800" y="4181856"/>
-            <a:ext cx="1171720" cy="182880"/>
+            <a:ext cx="1935885" cy="182880"/>
           </a:xfrm>
           <a:prstGeom prst="roundRect">
             <a:avLst>
@@ -33632,7 +33632,7 @@
                 <a:ea typeface="Poppins" pitchFamily="34" charset="-122"/>
                 <a:cs typeface="Poppins" pitchFamily="34" charset="-120"/>
               </a:rPr>
-              <a:t>US$360</a:t>
+              <a:t>US$595</a:t>
             </a:r>
             <a:endParaRPr lang="en-US" sz="900" dirty="0"/>
           </a:p>
@@ -33671,7 +33671,7 @@
                 <a:ea typeface="Poppins" pitchFamily="34" charset="-122"/>
                 <a:cs typeface="Poppins" pitchFamily="34" charset="-120"/>
               </a:rPr>
-              <a:t>7 deals</a:t>
+              <a:t>8 deals</a:t>
             </a:r>
             <a:endParaRPr lang="en-US" sz="750" dirty="0"/>
           </a:p>
@@ -33862,7 +33862,7 @@
         <p:spPr>
           <a:xfrm>
             <a:off x="1828800" y="4800600"/>
-            <a:ext cx="876762" cy="164592"/>
+            <a:ext cx="933138" cy="164592"/>
           </a:xfrm>
           <a:prstGeom prst="rect">
             <a:avLst/>
@@ -33882,7 +33882,7 @@
         <p:spPr>
           <a:xfrm>
             <a:off x="1828800" y="4782312"/>
-            <a:ext cx="876762" cy="201168"/>
+            <a:ext cx="933138" cy="201168"/>
           </a:xfrm>
           <a:prstGeom prst="rect">
             <a:avLst/>
@@ -33906,7 +33906,7 @@
                 <a:ea typeface="Poppins" pitchFamily="34" charset="-122"/>
                 <a:cs typeface="Poppins" pitchFamily="34" charset="-120"/>
               </a:rPr>
-              <a:t>18%</a:t>
+              <a:t>20%</a:t>
             </a:r>
             <a:endParaRPr lang="en-US" sz="650" dirty="0"/>
           </a:p>
@@ -33920,8 +33920,8 @@
         </p:nvSpPr>
         <p:spPr>
           <a:xfrm>
-            <a:off x="2723850" y="4800600"/>
-            <a:ext cx="3305677" cy="164592"/>
+            <a:off x="2780226" y="4800600"/>
+            <a:ext cx="2889718" cy="164592"/>
           </a:xfrm>
           <a:prstGeom prst="rect">
             <a:avLst/>
@@ -33940,8 +33940,8 @@
         </p:nvSpPr>
         <p:spPr>
           <a:xfrm>
-            <a:off x="2723850" y="4782312"/>
-            <a:ext cx="3305677" cy="201168"/>
+            <a:off x="2780226" y="4782312"/>
+            <a:ext cx="2889718" cy="201168"/>
           </a:xfrm>
           <a:prstGeom prst="rect">
             <a:avLst/>
@@ -33965,7 +33965,7 @@
                 <a:ea typeface="Poppins" pitchFamily="34" charset="-122"/>
                 <a:cs typeface="Poppins" pitchFamily="34" charset="-120"/>
               </a:rPr>
-              <a:t>70%</a:t>
+              <a:t>61%</a:t>
             </a:r>
             <a:endParaRPr lang="en-US" sz="650" dirty="0"/>
           </a:p>
@@ -33979,8 +33979,8 @@
         </p:nvSpPr>
         <p:spPr>
           <a:xfrm>
-            <a:off x="6047815" y="4800600"/>
-            <a:ext cx="572441" cy="164592"/>
+            <a:off x="5688233" y="4800600"/>
+            <a:ext cx="932023" cy="164592"/>
           </a:xfrm>
           <a:prstGeom prst="rect">
             <a:avLst/>
@@ -33999,8 +33999,8 @@
         </p:nvSpPr>
         <p:spPr>
           <a:xfrm>
-            <a:off x="6047815" y="4782312"/>
-            <a:ext cx="572441" cy="201168"/>
+            <a:off x="5688233" y="4782312"/>
+            <a:ext cx="932023" cy="201168"/>
           </a:xfrm>
           <a:prstGeom prst="rect">
             <a:avLst/>
@@ -34024,7 +34024,7 @@
                 <a:ea typeface="Poppins" pitchFamily="34" charset="-122"/>
                 <a:cs typeface="Poppins" pitchFamily="34" charset="-120"/>
               </a:rPr>
-              <a:t>12%</a:t>
+              <a:t>20%</a:t>
             </a:r>
             <a:endParaRPr lang="en-US" sz="650" dirty="0"/>
           </a:p>
@@ -34078,7 +34078,7 @@
         <p:spPr>
           <a:xfrm>
             <a:off x="1828800" y="5111496"/>
-            <a:ext cx="1046074" cy="164592"/>
+            <a:ext cx="1037428" cy="164592"/>
           </a:xfrm>
           <a:prstGeom prst="rect">
             <a:avLst/>
@@ -34098,7 +34098,7 @@
         <p:spPr>
           <a:xfrm>
             <a:off x="1828800" y="5093208"/>
-            <a:ext cx="1046074" cy="201168"/>
+            <a:ext cx="1037428" cy="201168"/>
           </a:xfrm>
           <a:prstGeom prst="rect">
             <a:avLst/>
@@ -34136,8 +34136,8 @@
         </p:nvSpPr>
         <p:spPr>
           <a:xfrm>
-            <a:off x="2893162" y="5111496"/>
-            <a:ext cx="3043123" cy="164592"/>
+            <a:off x="2884516" y="5111496"/>
+            <a:ext cx="3025833" cy="164592"/>
           </a:xfrm>
           <a:prstGeom prst="rect">
             <a:avLst/>
@@ -34156,8 +34156,8 @@
         </p:nvSpPr>
         <p:spPr>
           <a:xfrm>
-            <a:off x="2893162" y="5093208"/>
-            <a:ext cx="3043123" cy="201168"/>
+            <a:off x="2884516" y="5093208"/>
+            <a:ext cx="3025833" cy="201168"/>
           </a:xfrm>
           <a:prstGeom prst="rect">
             <a:avLst/>
@@ -34195,8 +34195,8 @@
         </p:nvSpPr>
         <p:spPr>
           <a:xfrm>
-            <a:off x="5954573" y="5111496"/>
-            <a:ext cx="665683" cy="164592"/>
+            <a:off x="5928637" y="5111496"/>
+            <a:ext cx="691619" cy="164592"/>
           </a:xfrm>
           <a:prstGeom prst="rect">
             <a:avLst/>
@@ -34215,8 +34215,8 @@
         </p:nvSpPr>
         <p:spPr>
           <a:xfrm>
-            <a:off x="5954573" y="5093208"/>
-            <a:ext cx="665683" cy="201168"/>
+            <a:off x="5928637" y="5093208"/>
+            <a:ext cx="691619" cy="201168"/>
           </a:xfrm>
           <a:prstGeom prst="rect">
             <a:avLst/>
@@ -34240,7 +34240,7 @@
                 <a:ea typeface="Poppins" pitchFamily="34" charset="-122"/>
                 <a:cs typeface="Poppins" pitchFamily="34" charset="-120"/>
               </a:rPr>
-              <a:t>14%</a:t>
+              <a:t>15%</a:t>
             </a:r>
             <a:endParaRPr lang="en-US" sz="650" dirty="0"/>
           </a:p>
@@ -34758,7 +34758,7 @@
                 <a:ea typeface="Poppins" pitchFamily="34" charset="-122"/>
                 <a:cs typeface="Poppins" pitchFamily="34" charset="-120"/>
               </a:rPr>
-              <a:t>US$1,229</a:t>
+              <a:t>US$1,207</a:t>
             </a:r>
             <a:endParaRPr lang="en-US" sz="750" dirty="0"/>
           </a:p>
@@ -34797,7 +34797,7 @@
                 <a:ea typeface="Poppins" pitchFamily="34" charset="-122"/>
                 <a:cs typeface="Poppins" pitchFamily="34" charset="-120"/>
               </a:rPr>
-              <a:t>US$552</a:t>
+              <a:t>US$596</a:t>
             </a:r>
             <a:endParaRPr lang="en-US" sz="750" dirty="0"/>
           </a:p>
@@ -34836,7 +34836,7 @@
                 <a:ea typeface="Poppins" pitchFamily="34" charset="-122"/>
                 <a:cs typeface="Poppins" pitchFamily="34" charset="-120"/>
               </a:rPr>
-              <a:t>US$147</a:t>
+              <a:t>US$170</a:t>
             </a:r>
             <a:endParaRPr lang="en-US" sz="750" dirty="0"/>
           </a:p>
@@ -34953,7 +34953,7 @@
                 <a:ea typeface="Poppins" pitchFamily="34" charset="-122"/>
                 <a:cs typeface="Poppins" pitchFamily="34" charset="-120"/>
               </a:rPr>
-              <a:t>US$852</a:t>
+              <a:t>US$639</a:t>
             </a:r>
             <a:endParaRPr lang="en-US" sz="750" dirty="0"/>
           </a:p>
@@ -35031,7 +35031,7 @@
                 <a:ea typeface="Poppins" pitchFamily="34" charset="-122"/>
                 <a:cs typeface="Poppins" pitchFamily="34" charset="-120"/>
               </a:rPr>
-              <a:t>US$213</a:t>
+              <a:t>US$426</a:t>
             </a:r>
             <a:endParaRPr lang="en-US" sz="750" dirty="0"/>
           </a:p>
@@ -35109,7 +35109,7 @@
                 <a:ea typeface="Poppins" pitchFamily="34" charset="-122"/>
                 <a:cs typeface="Poppins" pitchFamily="34" charset="-120"/>
               </a:rPr>
-              <a:t>9 lines on deals, every one priced $0</a:t>
+              <a:t>14 lines on deals, every one priced $0</a:t>
             </a:r>
             <a:endParaRPr lang="en-US" sz="530" dirty="0"/>
           </a:p>
@@ -35528,7 +35528,7 @@
                 <a:ea typeface="Poppins" pitchFamily="34" charset="-122"/>
                 <a:cs typeface="Poppins" pitchFamily="34" charset="-120"/>
               </a:rPr>
-              <a:t>US$14,751</a:t>
+              <a:t>US$14,486</a:t>
             </a:r>
             <a:endParaRPr lang="en-US" sz="1800" dirty="0"/>
           </a:p>
@@ -35567,7 +35567,7 @@
                 <a:ea typeface="Poppins" pitchFamily="34" charset="-122"/>
                 <a:cs typeface="Poppins" pitchFamily="34" charset="-120"/>
               </a:rPr>
-              <a:t>open ROAM pipeline at ×12 (A$20,712) — the contract value behind the US$2,081 of monthly lines</a:t>
+              <a:t>open ROAM pipeline at ×12 (A$20,340) — the contract value behind the US$1,846 of monthly lines</a:t>
             </a:r>
             <a:endParaRPr lang="en-US" sz="700" dirty="0"/>
           </a:p>
@@ -35744,7 +35744,7 @@
                 <a:ea typeface="Poppins" pitchFamily="34" charset="-122"/>
                 <a:cs typeface="Poppins" pitchFamily="34" charset="-120"/>
               </a:rPr>
-              <a:t>11 orders placed since 1 Jul (US$552) against 7 lost — 61% by count, 60% by value. All of it is ROAM; Sentinel has US$852 in play and no order yet.</a:t>
+              <a:t>12 orders placed since 1 Jul (US$596) against 8 lost — 60% by count, 50% by value. All of it is ROAM; Sentinel has US$639 in play and no order yet.</a:t>
             </a:r>
             <a:endParaRPr lang="en-US" sz="900" dirty="0"/>
           </a:p>
@@ -35792,7 +35792,7 @@
                 <a:ea typeface="Poppins" pitchFamily="34" charset="-122"/>
                 <a:cs typeface="Poppins" pitchFamily="34" charset="-120"/>
               </a:rPr>
-              <a:t>US$2,018 of the US$2,081 open sits in Quote Sent and Negotiation across 25 deals — the movement to chase is quote-to-order, not top-of-funnel.</a:t>
+              <a:t>US$1,783 of the US$1,846 open sits in Quote Sent and Negotiation across 24 deals — the movement to chase is quote-to-order, not top-of-funnel.</a:t>
             </a:r>
             <a:endParaRPr lang="en-US" sz="900" dirty="0"/>
           </a:p>
@@ -35826,7 +35826,7 @@
                 <a:ea typeface="Poppins" pitchFamily="34" charset="-122"/>
                 <a:cs typeface="Poppins" pitchFamily="34" charset="-120"/>
               </a:rPr>
-              <a:t>Two ROAM orders placed this week (Dave &amp; Busters Perth, Prendiville Norfolk — A$124) · QR Ordering lines still all $0 · 28 ROAM lines (A$2,170) on no deal are excluded.</a:t>
+              <a:t>26 Oct: Night Owl 393 Murray St placed (A$62), The Club Beaudesert lost (A$330), four $0 OrderNow demos opened · 28 ROAM lines (A$2,170) on no deal excluded.</a:t>
             </a:r>
             <a:endParaRPr lang="en-US" sz="900" dirty="0"/>
           </a:p>
@@ -35840,8 +35840,8 @@
         </p:nvSpPr>
         <p:spPr>
           <a:xfrm>
-            <a:off x="7585862" y="6510528"/>
-            <a:ext cx="4191610" cy="256032"/>
+            <a:off x="6839712" y="6510528"/>
+            <a:ext cx="4937760" cy="256032"/>
           </a:xfrm>
           <a:prstGeom prst="roundRect">
             <a:avLst>
@@ -35862,8 +35862,8 @@
         </p:nvSpPr>
         <p:spPr>
           <a:xfrm>
-            <a:off x="7585862" y="6510528"/>
-            <a:ext cx="4191610" cy="256032"/>
+            <a:off x="6839712" y="6510528"/>
+            <a:ext cx="4937760" cy="256032"/>
           </a:xfrm>
           <a:prstGeom prst="rect">
             <a:avLst/>
@@ -35887,7 +35887,7 @@
                 <a:ea typeface="Poppins" pitchFamily="34" charset="-122"/>
                 <a:cs typeface="Poppins" pitchFamily="34" charset="-120"/>
               </a:rPr>
-              <a:t>Source: HubSpot line items · products flagged ai_infused (live)</a:t>
+              <a:t>Source: HubSpot line items · products flagged ai_infused (live read 26 Oct)</a:t>
             </a:r>
             <a:endParaRPr lang="en-US" sz="700" dirty="0"/>
           </a:p>
@@ -39648,7 +39648,7 @@
                 <a:ea typeface="Poppins" pitchFamily="34" charset="-122"/>
                 <a:cs typeface="Poppins" pitchFamily="34" charset="-120"/>
               </a:rPr>
-              <a:t>11.5h</a:t>
+              <a:t>13.5h</a:t>
             </a:r>
             <a:pPr indent="0" marL="0">
               <a:buNone/>
@@ -39662,7 +39662,7 @@
                 <a:ea typeface="Poppins" pitchFamily="34" charset="-122"/>
                 <a:cs typeface="Poppins" pitchFamily="34" charset="-120"/>
               </a:rPr>
-              <a:t>  of 311.6h</a:t>
+              <a:t>  of 288.8h</a:t>
             </a:r>
             <a:endParaRPr lang="en-US" sz="2000" dirty="0"/>
           </a:p>
@@ -39701,7 +39701,7 @@
                 <a:ea typeface="Poppins" pitchFamily="34" charset="-122"/>
                 <a:cs typeface="Poppins" pitchFamily="34" charset="-120"/>
               </a:rPr>
-              <a:t>▼ from 51.0h last week</a:t>
+              <a:t>▼ from 60.0h last week</a:t>
             </a:r>
             <a:endParaRPr lang="en-US" sz="650" dirty="0"/>
           </a:p>
@@ -39828,7 +39828,7 @@
                 <a:ea typeface="Poppins" pitchFamily="34" charset="-122"/>
                 <a:cs typeface="Poppins" pitchFamily="34" charset="-120"/>
               </a:rPr>
-              <a:t>3.7%</a:t>
+              <a:t>4.7%</a:t>
             </a:r>
             <a:pPr indent="0" marL="0">
               <a:buNone/>
@@ -39881,7 +39881,7 @@
                 <a:ea typeface="Poppins" pitchFamily="34" charset="-122"/>
                 <a:cs typeface="Poppins" pitchFamily="34" charset="-120"/>
               </a:rPr>
-              <a:t>▼ from 16.8% last week</a:t>
+              <a:t>▼ from 19.7% last week</a:t>
             </a:r>
             <a:endParaRPr lang="en-US" sz="650" dirty="0"/>
           </a:p>
@@ -40022,7 +40022,7 @@
                 <a:ea typeface="Poppins" pitchFamily="34" charset="-122"/>
                 <a:cs typeface="Poppins" pitchFamily="34" charset="-120"/>
               </a:rPr>
-              <a:t>  91% of billable</a:t>
+              <a:t>  78% of billable</a:t>
             </a:r>
             <a:endParaRPr lang="en-US" sz="2000" dirty="0"/>
           </a:p>
@@ -40061,7 +40061,7 @@
                 <a:ea typeface="Poppins" pitchFamily="34" charset="-122"/>
                 <a:cs typeface="Poppins" pitchFamily="34" charset="-120"/>
               </a:rPr>
-              <a:t>▼ from 50.0h (98%) last week</a:t>
+              <a:t>▼ from 59.0h (98%) last week</a:t>
             </a:r>
             <a:endParaRPr lang="en-US" sz="650" dirty="0"/>
           </a:p>
@@ -40188,7 +40188,7 @@
                 <a:ea typeface="Poppins" pitchFamily="34" charset="-122"/>
                 <a:cs typeface="Poppins" pitchFamily="34" charset="-120"/>
               </a:rPr>
-              <a:t>1.0h</a:t>
+              <a:t>3.0h</a:t>
             </a:r>
             <a:pPr indent="0" marL="0">
               <a:buNone/>
@@ -40202,7 +40202,7 @@
                 <a:ea typeface="Poppins" pitchFamily="34" charset="-122"/>
                 <a:cs typeface="Poppins" pitchFamily="34" charset="-120"/>
               </a:rPr>
-              <a:t>  9% of billable</a:t>
+              <a:t>  22% of billable</a:t>
             </a:r>
             <a:endParaRPr lang="en-US" sz="2000" dirty="0"/>
           </a:p>
@@ -40241,7 +40241,7 @@
                 <a:ea typeface="Poppins" pitchFamily="34" charset="-122"/>
                 <a:cs typeface="Poppins" pitchFamily="34" charset="-120"/>
               </a:rPr>
-              <a:t>— from 1.0h (2%) last week</a:t>
+              <a:t>▲ from 1.0h (2%) last week</a:t>
             </a:r>
             <a:endParaRPr lang="en-US" sz="650" dirty="0"/>
           </a:p>
@@ -41305,7 +41305,7 @@
                 <a:ea typeface="Poppins" pitchFamily="34" charset="-122"/>
                 <a:cs typeface="Poppins" pitchFamily="34" charset="-120"/>
               </a:rPr>
-              <a:t>51.0h</a:t>
+              <a:t>60.0h</a:t>
             </a:r>
             <a:endParaRPr lang="en-US" sz="780" dirty="0"/>
           </a:p>
@@ -41344,7 +41344,7 @@
                 <a:ea typeface="Poppins" pitchFamily="34" charset="-122"/>
                 <a:cs typeface="Poppins" pitchFamily="34" charset="-120"/>
               </a:rPr>
-              <a:t>50.0h</a:t>
+              <a:t>59.0h</a:t>
             </a:r>
             <a:endParaRPr lang="en-US" sz="780" dirty="0"/>
           </a:p>
@@ -41422,7 +41422,7 @@
                 <a:ea typeface="Poppins" pitchFamily="34" charset="-122"/>
                 <a:cs typeface="Poppins" pitchFamily="34" charset="-120"/>
               </a:rPr>
-              <a:t>16.8%</a:t>
+              <a:t>19.7%</a:t>
             </a:r>
             <a:endParaRPr lang="en-US" sz="780" dirty="0"/>
           </a:p>
@@ -41461,7 +41461,7 @@
                 <a:ea typeface="Poppins" pitchFamily="34" charset="-122"/>
                 <a:cs typeface="Poppins" pitchFamily="34" charset="-120"/>
               </a:rPr>
-              <a:t>39.5h  ▲ +11.6h</a:t>
+              <a:t>39.5h  ▲ +20.6h</a:t>
             </a:r>
             <a:endParaRPr lang="en-US" sz="680" dirty="0"/>
           </a:p>
@@ -41559,7 +41559,7 @@
                 <a:ea typeface="Poppins" pitchFamily="34" charset="-122"/>
                 <a:cs typeface="Poppins" pitchFamily="34" charset="-120"/>
               </a:rPr>
-              <a:t>11.5h</a:t>
+              <a:t>13.5h</a:t>
             </a:r>
             <a:endParaRPr lang="en-US" sz="780" dirty="0"/>
           </a:p>
@@ -41637,7 +41637,7 @@
                 <a:ea typeface="Poppins" pitchFamily="34" charset="-122"/>
                 <a:cs typeface="Poppins" pitchFamily="34" charset="-120"/>
               </a:rPr>
-              <a:t>1.0h</a:t>
+              <a:t>3.0h</a:t>
             </a:r>
             <a:endParaRPr lang="en-US" sz="780" dirty="0"/>
           </a:p>
@@ -41676,7 +41676,7 @@
                 <a:ea typeface="Poppins" pitchFamily="34" charset="-122"/>
                 <a:cs typeface="Poppins" pitchFamily="34" charset="-120"/>
               </a:rPr>
-              <a:t>3.7%</a:t>
+              <a:t>4.7%</a:t>
             </a:r>
             <a:endParaRPr lang="en-US" sz="780" dirty="0"/>
           </a:p>
@@ -41707,15 +41707,15 @@
               <a:buNone/>
             </a:pPr>
             <a:r>
-              <a:rPr lang="en-US" sz="680" dirty="0">
-                <a:solidFill>
-                  <a:srgbClr val="8FA1AC"/>
-                </a:solidFill>
-                <a:latin typeface="Poppins" pitchFamily="34" charset="0"/>
-                <a:ea typeface="Poppins" pitchFamily="34" charset="-122"/>
-                <a:cs typeface="Poppins" pitchFamily="34" charset="-120"/>
-              </a:rPr>
-              <a:t>first report</a:t>
+              <a:rPr lang="en-US" sz="680" b="1" dirty="0">
+                <a:solidFill>
+                  <a:srgbClr val="B4552D"/>
+                </a:solidFill>
+                <a:latin typeface="Poppins" pitchFamily="34" charset="0"/>
+                <a:ea typeface="Poppins" pitchFamily="34" charset="-122"/>
+                <a:cs typeface="Poppins" pitchFamily="34" charset="-120"/>
+              </a:rPr>
+              <a:t>11.5h  ▲ +2.0h</a:t>
             </a:r>
             <a:endParaRPr lang="en-US" sz="680" dirty="0"/>
           </a:p>
@@ -44448,7 +44448,7 @@
                 <a:ea typeface="Poppins" pitchFamily="34" charset="-122"/>
                 <a:cs typeface="Poppins" pitchFamily="34" charset="-120"/>
               </a:rPr>
-              <a:t>Solotel</a:t>
+              <a:t>Perks Hospitality</a:t>
             </a:r>
             <a:endParaRPr lang="en-US" sz="680" dirty="0"/>
           </a:p>
@@ -44487,7 +44487,7 @@
                 <a:ea typeface="Poppins" pitchFamily="34" charset="-122"/>
                 <a:cs typeface="Poppins" pitchFamily="34" charset="-120"/>
               </a:rPr>
-              <a:t>7.0h</a:t>
+              <a:t>10.0h</a:t>
             </a:r>
             <a:endParaRPr lang="en-US" sz="680" dirty="0"/>
           </a:p>
@@ -44526,7 +44526,7 @@
                 <a:ea typeface="Poppins" pitchFamily="34" charset="-122"/>
                 <a:cs typeface="Poppins" pitchFamily="34" charset="-120"/>
               </a:rPr>
-              <a:t>7.0h</a:t>
+              <a:t>10.0h</a:t>
             </a:r>
             <a:endParaRPr lang="en-US" sz="680" dirty="0"/>
           </a:p>
@@ -44643,7 +44643,7 @@
                 <a:ea typeface="Poppins" pitchFamily="34" charset="-122"/>
                 <a:cs typeface="Poppins" pitchFamily="34" charset="-120"/>
               </a:rPr>
-              <a:t>Trader House</a:t>
+              <a:t>Solotel</a:t>
             </a:r>
             <a:endParaRPr lang="en-US" sz="680" dirty="0"/>
           </a:p>
@@ -44682,7 +44682,7 @@
                 <a:ea typeface="Poppins" pitchFamily="34" charset="-122"/>
                 <a:cs typeface="Poppins" pitchFamily="34" charset="-120"/>
               </a:rPr>
-              <a:t>3.5h</a:t>
+              <a:t>7.0h</a:t>
             </a:r>
             <a:endParaRPr lang="en-US" sz="680" dirty="0"/>
           </a:p>
@@ -44721,7 +44721,7 @@
                 <a:ea typeface="Poppins" pitchFamily="34" charset="-122"/>
                 <a:cs typeface="Poppins" pitchFamily="34" charset="-120"/>
               </a:rPr>
-              <a:t>3.5h</a:t>
+              <a:t>7.0h</a:t>
             </a:r>
             <a:endParaRPr lang="en-US" sz="680" dirty="0"/>
           </a:p>
@@ -44858,7 +44858,7 @@
                 <a:ea typeface="Poppins" pitchFamily="34" charset="-122"/>
                 <a:cs typeface="Poppins" pitchFamily="34" charset="-120"/>
               </a:rPr>
-              <a:t>Locals Co</a:t>
+              <a:t>Trader House</a:t>
             </a:r>
             <a:endParaRPr lang="en-US" sz="680" dirty="0"/>
           </a:p>
@@ -45053,7 +45053,7 @@
                 <a:ea typeface="Poppins" pitchFamily="34" charset="-122"/>
                 <a:cs typeface="Poppins" pitchFamily="34" charset="-120"/>
               </a:rPr>
-              <a:t>HHG</a:t>
+              <a:t>Locals Co</a:t>
             </a:r>
             <a:endParaRPr lang="en-US" sz="680" dirty="0"/>
           </a:p>
@@ -45268,7 +45268,7 @@
                 <a:ea typeface="Poppins" pitchFamily="34" charset="-122"/>
                 <a:cs typeface="Poppins" pitchFamily="34" charset="-120"/>
               </a:rPr>
-              <a:t>Lucas Collective</a:t>
+              <a:t>HHG</a:t>
             </a:r>
             <a:endParaRPr lang="en-US" sz="680" dirty="0"/>
           </a:p>
@@ -45307,7 +45307,7 @@
                 <a:ea typeface="Poppins" pitchFamily="34" charset="-122"/>
                 <a:cs typeface="Poppins" pitchFamily="34" charset="-120"/>
               </a:rPr>
-              <a:t>3.0h</a:t>
+              <a:t>3.5h</a:t>
             </a:r>
             <a:endParaRPr lang="en-US" sz="680" dirty="0"/>
           </a:p>
@@ -45346,7 +45346,7 @@
                 <a:ea typeface="Poppins" pitchFamily="34" charset="-122"/>
                 <a:cs typeface="Poppins" pitchFamily="34" charset="-120"/>
               </a:rPr>
-              <a:t>3.0h</a:t>
+              <a:t>3.5h</a:t>
             </a:r>
             <a:endParaRPr lang="en-US" sz="680" dirty="0"/>
           </a:p>
@@ -45463,7 +45463,7 @@
                 <a:ea typeface="Poppins" pitchFamily="34" charset="-122"/>
                 <a:cs typeface="Poppins" pitchFamily="34" charset="-120"/>
               </a:rPr>
-              <a:t>Liquor Barons</a:t>
+              <a:t>Lucas Collective</a:t>
             </a:r>
             <a:endParaRPr lang="en-US" sz="680" dirty="0"/>
           </a:p>
@@ -45502,7 +45502,7 @@
                 <a:ea typeface="Poppins" pitchFamily="34" charset="-122"/>
                 <a:cs typeface="Poppins" pitchFamily="34" charset="-120"/>
               </a:rPr>
-              <a:t>2.5h</a:t>
+              <a:t>3.0h</a:t>
             </a:r>
             <a:endParaRPr lang="en-US" sz="680" dirty="0"/>
           </a:p>
@@ -45541,7 +45541,7 @@
                 <a:ea typeface="Poppins" pitchFamily="34" charset="-122"/>
                 <a:cs typeface="Poppins" pitchFamily="34" charset="-120"/>
               </a:rPr>
-              <a:t>2.5h</a:t>
+              <a:t>3.0h</a:t>
             </a:r>
             <a:endParaRPr lang="en-US" sz="680" dirty="0"/>
           </a:p>
@@ -45678,7 +45678,7 @@
                 <a:ea typeface="Poppins" pitchFamily="34" charset="-122"/>
                 <a:cs typeface="Poppins" pitchFamily="34" charset="-120"/>
               </a:rPr>
-              <a:t>BRG</a:t>
+              <a:t>Liquor Barons</a:t>
             </a:r>
             <a:endParaRPr lang="en-US" sz="680" dirty="0"/>
           </a:p>
@@ -45717,7 +45717,7 @@
                 <a:ea typeface="Poppins" pitchFamily="34" charset="-122"/>
                 <a:cs typeface="Poppins" pitchFamily="34" charset="-120"/>
               </a:rPr>
-              <a:t>2.1h</a:t>
+              <a:t>2.5h</a:t>
             </a:r>
             <a:endParaRPr lang="en-US" sz="680" dirty="0"/>
           </a:p>
@@ -45756,7 +45756,7 @@
                 <a:ea typeface="Poppins" pitchFamily="34" charset="-122"/>
                 <a:cs typeface="Poppins" pitchFamily="34" charset="-120"/>
               </a:rPr>
-              <a:t>2.1h</a:t>
+              <a:t>2.5h</a:t>
             </a:r>
             <a:endParaRPr lang="en-US" sz="680" dirty="0"/>
           </a:p>
@@ -45873,7 +45873,7 @@
                 <a:ea typeface="Poppins" pitchFamily="34" charset="-122"/>
                 <a:cs typeface="Poppins" pitchFamily="34" charset="-120"/>
               </a:rPr>
-              <a:t>Perks Hospitality</a:t>
+              <a:t>BRG</a:t>
             </a:r>
             <a:endParaRPr lang="en-US" sz="680" dirty="0"/>
           </a:p>
@@ -45912,7 +45912,7 @@
                 <a:ea typeface="Poppins" pitchFamily="34" charset="-122"/>
                 <a:cs typeface="Poppins" pitchFamily="34" charset="-120"/>
               </a:rPr>
-              <a:t>2.0h</a:t>
+              <a:t>2.1h</a:t>
             </a:r>
             <a:endParaRPr lang="en-US" sz="680" dirty="0"/>
           </a:p>
@@ -45951,7 +45951,7 @@
                 <a:ea typeface="Poppins" pitchFamily="34" charset="-122"/>
                 <a:cs typeface="Poppins" pitchFamily="34" charset="-120"/>
               </a:rPr>
-              <a:t>2.0h</a:t>
+              <a:t>2.1h</a:t>
             </a:r>
             <a:endParaRPr lang="en-US" sz="680" dirty="0"/>
           </a:p>
@@ -46198,7 +46198,7 @@
                 <a:ea typeface="Poppins" pitchFamily="34" charset="-122"/>
                 <a:cs typeface="Poppins" pitchFamily="34" charset="-120"/>
               </a:rPr>
-              <a:t>Q4's hidden work so far: 20h, $3,000 of unrecognised PS revenue. </a:t>
+              <a:t>Q4's hidden work so far: 22h, $3,300 of unrecognised PS revenue. </a:t>
             </a:r>
             <a:pPr indent="0" marL="0">
               <a:spcAft>
@@ -46215,7 +46215,7 @@
                 <a:ea typeface="Poppins" pitchFamily="34" charset="-122"/>
                 <a:cs typeface="Poppins" pitchFamily="34" charset="-120"/>
               </a:rPr>
-              <a:t>AVC's 9.2 upgrades (18h, $2,700) and H&amp;L Pay activations (2h, $300). </a:t>
+              <a:t>AVC's 9.2 upgrades (18h, $2,700) and four H&amp;L Pay activations (4h, $600) — two not yet tagged H&amp;L Pay on Integration Level 3.</a:t>
             </a:r>
             <a:endParaRPr lang="en-US" sz="900" dirty="0"/>
           </a:p>
@@ -52613,7 +52613,7 @@
                 <a:ea typeface="Poppins" pitchFamily="34" charset="-122"/>
                 <a:cs typeface="Poppins" pitchFamily="34" charset="-120"/>
               </a:rPr>
-              <a:t>597 closed against 396 new this week — net −201, the biggest weekly fall in six months. Open is 389, down from 588.</a:t>
+              <a:t>595 closed against 395 new this week — net −200, the biggest weekly fall in six months. Open is 389, down from 588.</a:t>
             </a:r>
             <a:endParaRPr lang="en-US" sz="900" dirty="0"/>
           </a:p>

</xml_diff>